<commit_message>
Add HLD and LLD to the deck
Six slides. The high-level design is drawn rather than described: static
origin, browser, model provider, and the optional backend, with the trust
boundaries marked - the point being that no server is operated and no key
is held by the project.

The low-level design names what actually exists, read from the tree rather
than recalled: the module map with real line counts, one AI step end to end
through draw, callModel, extractJson and applyAction, both data contracts
field by field, and the four ways a lane can terminate.

The diagram checks its own labels stay inside the axes, for the same reason
the scatter measures its labels: the slides cannot be rendered here, so
anything not measured is unverified.

Co-Authored-By: Claude Opus 5 <noreply@anthropic.com>
</commit_message>
<xml_diff>
--- a/docs/MNIST-PRO-overview.pptx
+++ b/docs/MNIST-PRO-overview.pptx
@@ -24,6 +24,12 @@
     <p:sldId id="272" r:id="rId23"/>
     <p:sldId id="273" r:id="rId24"/>
     <p:sldId id="274" r:id="rId25"/>
+    <p:sldId id="275" r:id="rId26"/>
+    <p:sldId id="276" r:id="rId27"/>
+    <p:sldId id="277" r:id="rId28"/>
+    <p:sldId id="278" r:id="rId29"/>
+    <p:sldId id="279" r:id="rId30"/>
+    <p:sldId id="280" r:id="rId31"/>
   </p:sldIdLst>
   <p:sldSz cx="12191695" cy="6858000" type="screen4x3"/>
   <p:notesSz cx="6858000" cy="9144000"/>
@@ -5814,7 +5820,7 @@
                 </a:solidFill>
                 <a:latin typeface="Segoe UI"/>
               </a:rPr>
-              <a:t>DESIGN</a:t>
+              <a:t>HIGH-LEVEL DESIGN</a:t>
             </a:r>
           </a:p>
         </p:txBody>
@@ -5853,323 +5859,35 @@
                 </a:solidFill>
                 <a:latin typeface="Segoe UI"/>
               </a:rPr>
-              <a:t>Decisions, and why they went that way</a:t>
-            </a:r>
-          </a:p>
-        </p:txBody>
-      </p:sp>
-      <p:sp>
-        <p:nvSpPr>
-          <p:cNvPr id="6" name="TextBox 5"/>
-          <p:cNvSpPr txBox="1"/>
-          <p:nvPr/>
-        </p:nvSpPr>
-        <p:spPr>
-          <a:xfrm>
-            <a:off x="868680" y="1783080"/>
-            <a:ext cx="10607040" cy="246761"/>
-          </a:xfrm>
-          <a:prstGeom prst="rect">
-            <a:avLst/>
-          </a:prstGeom>
-          <a:noFill/>
-        </p:spPr>
-        <p:txBody>
-          <a:bodyPr wrap="square">
-            <a:spAutoFit/>
-          </a:bodyPr>
-          <a:lstStyle/>
-          <a:p>
-            <a:pPr algn="l">
-              <a:lnSpc>
-                <a:spcPct val="115000"/>
-              </a:lnSpc>
-            </a:pPr>
-            <a:r>
-              <a:rPr sz="1450" b="1" i="0">
-                <a:solidFill>
-                  <a:srgbClr val="141B2D"/>
-                </a:solidFill>
-                <a:latin typeface="Segoe UI"/>
-              </a:rPr>
-              <a:t>ARC first, MNIST-PRO second.</a:t>
-            </a:r>
-          </a:p>
-        </p:txBody>
-      </p:sp>
-      <p:sp>
-        <p:nvSpPr>
-          <p:cNvPr id="7" name="TextBox 6"/>
-          <p:cNvSpPr txBox="1"/>
-          <p:nvPr/>
-        </p:nvSpPr>
-        <p:spPr>
-          <a:xfrm>
-            <a:off x="868680" y="2066416"/>
-            <a:ext cx="10607040" cy="414528"/>
-          </a:xfrm>
-          <a:prstGeom prst="rect">
-            <a:avLst/>
-          </a:prstGeom>
-          <a:noFill/>
-        </p:spPr>
-        <p:txBody>
-          <a:bodyPr wrap="square">
-            <a:spAutoFit/>
-          </a:bodyPr>
-          <a:lstStyle/>
-          <a:p>
-            <a:pPr algn="l">
-              <a:lnSpc>
-                <a:spcPct val="125000"/>
-              </a:lnSpc>
-            </a:pPr>
-            <a:r>
-              <a:rPr sz="1200" b="0" i="0">
-                <a:solidFill>
-                  <a:srgbClr val="5A667A"/>
-                </a:solidFill>
-                <a:latin typeface="Segoe UI"/>
-              </a:rPr>
-              <a:t>ARC asks you to infer a rule in five minutes. That turned out to be the wrong kind of hard for a party game, so a task needing no prior knowledge became the front page.</a:t>
-            </a:r>
-          </a:p>
-        </p:txBody>
-      </p:sp>
-      <p:sp>
-        <p:nvSpPr>
-          <p:cNvPr id="8" name="TextBox 7"/>
-          <p:cNvSpPr txBox="1"/>
-          <p:nvPr/>
-        </p:nvSpPr>
-        <p:spPr>
-          <a:xfrm>
-            <a:off x="868680" y="2590673"/>
-            <a:ext cx="10607040" cy="246761"/>
-          </a:xfrm>
-          <a:prstGeom prst="rect">
-            <a:avLst/>
-          </a:prstGeom>
-          <a:noFill/>
-        </p:spPr>
-        <p:txBody>
-          <a:bodyPr wrap="square">
-            <a:spAutoFit/>
-          </a:bodyPr>
-          <a:lstStyle/>
-          <a:p>
-            <a:pPr algn="l">
-              <a:lnSpc>
-                <a:spcPct val="115000"/>
-              </a:lnSpc>
-            </a:pPr>
-            <a:r>
-              <a:rPr sz="1450" b="1" i="0">
-                <a:solidFill>
-                  <a:srgbClr val="141B2D"/>
-                </a:solidFill>
-                <a:latin typeface="Segoe UI"/>
-              </a:rPr>
-              <a:t>Difficulty measured rather than asserted.</a:t>
-            </a:r>
-          </a:p>
-        </p:txBody>
-      </p:sp>
-      <p:sp>
-        <p:nvSpPr>
-          <p:cNvPr id="9" name="TextBox 8"/>
-          <p:cNvSpPr txBox="1"/>
-          <p:nvPr/>
-        </p:nvSpPr>
-        <p:spPr>
-          <a:xfrm>
-            <a:off x="868680" y="2874010"/>
-            <a:ext cx="10607040" cy="414528"/>
-          </a:xfrm>
-          <a:prstGeom prst="rect">
-            <a:avLst/>
-          </a:prstGeom>
-          <a:noFill/>
-        </p:spPr>
-        <p:txBody>
-          <a:bodyPr wrap="square">
-            <a:spAutoFit/>
-          </a:bodyPr>
-          <a:lstStyle/>
-          <a:p>
-            <a:pPr algn="l">
-              <a:lnSpc>
-                <a:spcPct val="125000"/>
-              </a:lnSpc>
-            </a:pPr>
-            <a:r>
-              <a:rPr sz="1200" b="0" i="0">
-                <a:solidFill>
-                  <a:srgbClr val="5A667A"/>
-                </a:solidFill>
-                <a:latin typeface="Segoe UI"/>
-              </a:rPr>
-              <a:t>For ARC, a classifier found the 19 tasks a single rule explains. For MNIST-PRO, a simulation of 400 digits set the window size: 8x8 tiles end a round in 2 glimpses, 2x2 in 15. 4x4 was the playable middle.</a:t>
-            </a:r>
-          </a:p>
-        </p:txBody>
-      </p:sp>
-      <p:sp>
-        <p:nvSpPr>
-          <p:cNvPr id="10" name="TextBox 9"/>
-          <p:cNvSpPr txBox="1"/>
-          <p:nvPr/>
-        </p:nvSpPr>
-        <p:spPr>
-          <a:xfrm>
-            <a:off x="868680" y="3398266"/>
-            <a:ext cx="10607040" cy="246761"/>
-          </a:xfrm>
-          <a:prstGeom prst="rect">
-            <a:avLst/>
-          </a:prstGeom>
-          <a:noFill/>
-        </p:spPr>
-        <p:txBody>
-          <a:bodyPr wrap="square">
-            <a:spAutoFit/>
-          </a:bodyPr>
-          <a:lstStyle/>
-          <a:p>
-            <a:pPr algn="l">
-              <a:lnSpc>
-                <a:spcPct val="115000"/>
-              </a:lnSpc>
-            </a:pPr>
-            <a:r>
-              <a:rPr sz="1450" b="1" i="0">
-                <a:solidFill>
-                  <a:srgbClr val="141B2D"/>
-                </a:solidFill>
-                <a:latin typeface="Segoe UI"/>
-              </a:rPr>
-              <a:t>Steps, not seconds.</a:t>
-            </a:r>
-          </a:p>
-        </p:txBody>
-      </p:sp>
-      <p:sp>
-        <p:nvSpPr>
-          <p:cNvPr id="11" name="TextBox 10"/>
-          <p:cNvSpPr txBox="1"/>
-          <p:nvPr/>
-        </p:nvSpPr>
-        <p:spPr>
-          <a:xfrm>
-            <a:off x="868680" y="3681603"/>
-            <a:ext cx="10607040" cy="207264"/>
-          </a:xfrm>
-          <a:prstGeom prst="rect">
-            <a:avLst/>
-          </a:prstGeom>
-          <a:noFill/>
-        </p:spPr>
-        <p:txBody>
-          <a:bodyPr wrap="square">
-            <a:spAutoFit/>
-          </a:bodyPr>
-          <a:lstStyle/>
-          <a:p>
-            <a:pPr algn="l">
-              <a:lnSpc>
-                <a:spcPct val="125000"/>
-              </a:lnSpc>
-            </a:pPr>
-            <a:r>
-              <a:rPr sz="1200" b="0" i="0">
-                <a:solidFill>
-                  <a:srgbClr val="5A667A"/>
-                </a:solidFill>
-                <a:latin typeface="Segoe UI"/>
-              </a:rPr>
-              <a:t>Suggested by the first player to look at it, and correct: timing a networked opponent measures latency.</a:t>
-            </a:r>
-          </a:p>
-        </p:txBody>
-      </p:sp>
-      <p:sp>
-        <p:nvSpPr>
-          <p:cNvPr id="12" name="TextBox 11"/>
-          <p:cNvSpPr txBox="1"/>
-          <p:nvPr/>
-        </p:nvSpPr>
-        <p:spPr>
-          <a:xfrm>
-            <a:off x="868680" y="3998595"/>
-            <a:ext cx="10607040" cy="246761"/>
-          </a:xfrm>
-          <a:prstGeom prst="rect">
-            <a:avLst/>
-          </a:prstGeom>
-          <a:noFill/>
-        </p:spPr>
-        <p:txBody>
-          <a:bodyPr wrap="square">
-            <a:spAutoFit/>
-          </a:bodyPr>
-          <a:lstStyle/>
-          <a:p>
-            <a:pPr algn="l">
-              <a:lnSpc>
-                <a:spcPct val="115000"/>
-              </a:lnSpc>
-            </a:pPr>
-            <a:r>
-              <a:rPr sz="1450" b="1" i="0">
-                <a:solidFill>
-                  <a:srgbClr val="141B2D"/>
-                </a:solidFill>
-                <a:latin typeface="Segoe UI"/>
-              </a:rPr>
-              <a:t>The rules panel collapsed by default.</a:t>
-            </a:r>
-          </a:p>
-        </p:txBody>
-      </p:sp>
-      <p:sp>
-        <p:nvSpPr>
-          <p:cNvPr id="13" name="TextBox 12"/>
-          <p:cNvSpPr txBox="1"/>
-          <p:nvPr/>
-        </p:nvSpPr>
-        <p:spPr>
-          <a:xfrm>
-            <a:off x="868680" y="4281932"/>
-            <a:ext cx="10607040" cy="207264"/>
-          </a:xfrm>
-          <a:prstGeom prst="rect">
-            <a:avLst/>
-          </a:prstGeom>
-          <a:noFill/>
-        </p:spPr>
-        <p:txBody>
-          <a:bodyPr wrap="square">
-            <a:spAutoFit/>
-          </a:bodyPr>
-          <a:lstStyle/>
-          <a:p>
-            <a:pPr algn="l">
-              <a:lnSpc>
-                <a:spcPct val="125000"/>
-              </a:lnSpc>
-            </a:pPr>
-            <a:r>
-              <a:rPr sz="1200" b="0" i="0">
-                <a:solidFill>
-                  <a:srgbClr val="5A667A"/>
-                </a:solidFill>
-                <a:latin typeface="Segoe UI"/>
-              </a:rPr>
-              <a:t>It occupied the top of both games before anyone had pressed anything.</a:t>
-            </a:r>
-          </a:p>
-        </p:txBody>
-      </p:sp>
+              <a:t>Three parties, one of them optional</a:t>
+            </a:r>
+          </a:p>
+        </p:txBody>
+      </p:sp>
+      <p:pic>
+        <p:nvPicPr>
+          <p:cNvPr id="6" name="Picture 5" descr="chart_hld.png"/>
+          <p:cNvPicPr>
+            <a:picLocks noChangeAspect="1"/>
+          </p:cNvPicPr>
+          <p:nvPr/>
+        </p:nvPicPr>
+        <p:blipFill>
+          <a:blip r:embed="rId2"/>
+          <a:stretch>
+            <a:fillRect/>
+          </a:stretch>
+        </p:blipFill>
+        <p:spPr>
+          <a:xfrm>
+            <a:off x="868680" y="1600200"/>
+            <a:ext cx="10424160" cy="4572000"/>
+          </a:xfrm>
+          <a:prstGeom prst="rect">
+            <a:avLst/>
+          </a:prstGeom>
+        </p:spPr>
+      </p:pic>
     </p:spTree>
   </p:cSld>
   <p:clrMapOvr>
@@ -6310,7 +6028,7 @@
                 </a:solidFill>
                 <a:latin typeface="Segoe UI"/>
               </a:rPr>
-              <a:t>WHAT BUILDING IT TAUGHT US</a:t>
+              <a:t>HIGH-LEVEL DESIGN</a:t>
             </a:r>
           </a:p>
         </p:txBody>
@@ -6349,7 +6067,7 @@
                 </a:solidFill>
                 <a:latin typeface="Segoe UI"/>
               </a:rPr>
-              <a:t>The tests agreed with me more often than they should have</a:t>
+              <a:t>Where the trust boundaries fall</a:t>
             </a:r>
           </a:p>
         </p:txBody>
@@ -6388,7 +6106,7 @@
                 </a:solidFill>
                 <a:latin typeface="Segoe UI"/>
               </a:rPr>
-              <a:t>Five real bugs were caught by looking at screenshots, not by assertions.</a:t>
+              <a:t>The static origin holds no secrets, because it cannot hold anything.</a:t>
             </a:r>
           </a:p>
         </p:txBody>
@@ -6427,7 +6145,7 @@
                 </a:solidFill>
                 <a:latin typeface="Segoe UI"/>
               </a:rPr>
-              <a:t>A correct answer reported as 'Wrong - it answered null'. Panels frozen on a stale state. Overlays sitting on top of live canvases. Sensible actions rejected on formatting. A reply cut off by a token budget and scored as malformed.</a:t>
+              <a:t>GitHub Pages serves bytes. Every ARC answer it serves is a SHA-256 digest, and every MNIST canvas is a packed bitmap - correct to render, useless as an answer key.</a:t>
             </a:r>
           </a:p>
         </p:txBody>
@@ -6440,7 +6158,7 @@
         </p:nvSpPr>
         <p:spPr>
           <a:xfrm>
-            <a:off x="868680" y="2581529"/>
+            <a:off x="868680" y="2599817"/>
             <a:ext cx="10607040" cy="246761"/>
           </a:xfrm>
           <a:prstGeom prst="rect">
@@ -6466,7 +6184,7 @@
                 </a:solidFill>
                 <a:latin typeface="Segoe UI"/>
               </a:rPr>
-              <a:t>The common thread: asserting intent instead of outcome.</a:t>
+              <a:t>The browser is the only place a key exists, and only if the visitor brings one.</a:t>
             </a:r>
           </a:p>
         </p:txBody>
@@ -6479,7 +6197,7 @@
         </p:nvSpPr>
         <p:spPr>
           <a:xfrm>
-            <a:off x="868680" y="2864866"/>
+            <a:off x="868680" y="2883154"/>
             <a:ext cx="10607040" cy="414528"/>
           </a:xfrm>
           <a:prstGeom prst="rect">
@@ -6505,7 +6223,7 @@
                 </a:solidFill>
                 <a:latin typeface="Segoe UI"/>
               </a:rPr>
-              <a:t>Tests checked that hidden was set - it was - while the element stayed on screen, because an explicit CSS display beats the hidden attribute. Every such test passed throughout.</a:t>
+              <a:t>Held in localStorage, sent to openrouter.ai and nowhere else. Solo play never needs one, and the project's own key has never been in the repository.</a:t>
             </a:r>
           </a:p>
         </p:txBody>
@@ -6518,7 +6236,7 @@
         </p:nvSpPr>
         <p:spPr>
           <a:xfrm>
-            <a:off x="868680" y="3379978"/>
+            <a:off x="868680" y="3416553"/>
             <a:ext cx="10607040" cy="246761"/>
           </a:xfrm>
           <a:prstGeom prst="rect">
@@ -6544,7 +6262,7 @@
                 </a:solidFill>
                 <a:latin typeface="Segoe UI"/>
               </a:rPr>
-              <a:t>Fixes applied per-place rather than once come back.</a:t>
+              <a:t>The model sees one glimpse at a time and nothing else.</a:t>
             </a:r>
           </a:p>
         </p:txBody>
@@ -6557,7 +6275,85 @@
         </p:nvSpPr>
         <p:spPr>
           <a:xfrm>
-            <a:off x="868680" y="3663314"/>
+            <a:off x="868680" y="3699890"/>
+            <a:ext cx="10607040" cy="207264"/>
+          </a:xfrm>
+          <a:prstGeom prst="rect">
+            <a:avLst/>
+          </a:prstGeom>
+          <a:noFill/>
+        </p:spPr>
+        <p:txBody>
+          <a:bodyPr wrap="square">
+            <a:spAutoFit/>
+          </a:bodyPr>
+          <a:lstStyle/>
+          <a:p>
+            <a:pPr algn="l">
+              <a:lnSpc>
+                <a:spcPct val="125000"/>
+              </a:lnSpc>
+            </a:pPr>
+            <a:r>
+              <a:rPr sz="1200" b="0" i="0">
+                <a:solidFill>
+                  <a:srgbClr val="5A667A"/>
+                </a:solidFill>
+                <a:latin typeface="Segoe UI"/>
+              </a:rPr>
+              <a:t>A PNG of the current window plus the running transcript. It never receives the whole canvas, the label, or the human's progress.</a:t>
+            </a:r>
+          </a:p>
+        </p:txBody>
+      </p:sp>
+      <p:sp>
+        <p:nvSpPr>
+          <p:cNvPr id="12" name="TextBox 11"/>
+          <p:cNvSpPr txBox="1"/>
+          <p:nvPr/>
+        </p:nvSpPr>
+        <p:spPr>
+          <a:xfrm>
+            <a:off x="868680" y="4026026"/>
+            <a:ext cx="10607040" cy="246761"/>
+          </a:xfrm>
+          <a:prstGeom prst="rect">
+            <a:avLst/>
+          </a:prstGeom>
+          <a:noFill/>
+        </p:spPr>
+        <p:txBody>
+          <a:bodyPr wrap="square">
+            <a:spAutoFit/>
+          </a:bodyPr>
+          <a:lstStyle/>
+          <a:p>
+            <a:pPr algn="l">
+              <a:lnSpc>
+                <a:spcPct val="115000"/>
+              </a:lnSpc>
+            </a:pPr>
+            <a:r>
+              <a:rPr sz="1450" b="1" i="0">
+                <a:solidFill>
+                  <a:srgbClr val="141B2D"/>
+                </a:solidFill>
+                <a:latin typeface="Segoe UI"/>
+              </a:rPr>
+              <a:t>The backend is optional and currently undeployed.</a:t>
+            </a:r>
+          </a:p>
+        </p:txBody>
+      </p:sp>
+      <p:sp>
+        <p:nvSpPr>
+          <p:cNvPr id="13" name="TextBox 12"/>
+          <p:cNvSpPr txBox="1"/>
+          <p:nvPr/>
+        </p:nvSpPr>
+        <p:spPr>
+          <a:xfrm>
+            <a:off x="868680" y="4309364"/>
             <a:ext cx="10607040" cy="414528"/>
           </a:xfrm>
           <a:prstGeom prst="rect">
@@ -6583,85 +6379,7 @@
                 </a:solidFill>
                 <a:latin typeface="Segoe UI"/>
               </a:rPr>
-              <a:t>The hidden-attribute bug was patched in four components before being fixed globally. The token-budget check existed in two other code paths and was missing from the third.</a:t>
-            </a:r>
-          </a:p>
-        </p:txBody>
-      </p:sp>
-      <p:sp>
-        <p:nvSpPr>
-          <p:cNvPr id="12" name="TextBox 11"/>
-          <p:cNvSpPr txBox="1"/>
-          <p:nvPr/>
-        </p:nvSpPr>
-        <p:spPr>
-          <a:xfrm>
-            <a:off x="868680" y="4178427"/>
-            <a:ext cx="10607040" cy="246761"/>
-          </a:xfrm>
-          <a:prstGeom prst="rect">
-            <a:avLst/>
-          </a:prstGeom>
-          <a:noFill/>
-        </p:spPr>
-        <p:txBody>
-          <a:bodyPr wrap="square">
-            <a:spAutoFit/>
-          </a:bodyPr>
-          <a:lstStyle/>
-          <a:p>
-            <a:pPr algn="l">
-              <a:lnSpc>
-                <a:spcPct val="115000"/>
-              </a:lnSpc>
-            </a:pPr>
-            <a:r>
-              <a:rPr sz="1450" b="1" i="0">
-                <a:solidFill>
-                  <a:srgbClr val="141B2D"/>
-                </a:solidFill>
-                <a:latin typeface="Segoe UI"/>
-              </a:rPr>
-              <a:t>Diagnostics are a feature.</a:t>
-            </a:r>
-          </a:p>
-        </p:txBody>
-      </p:sp>
-      <p:sp>
-        <p:nvSpPr>
-          <p:cNvPr id="13" name="TextBox 12"/>
-          <p:cNvSpPr txBox="1"/>
-          <p:nvPr/>
-        </p:nvSpPr>
-        <p:spPr>
-          <a:xfrm>
-            <a:off x="868680" y="4461764"/>
-            <a:ext cx="10607040" cy="207264"/>
-          </a:xfrm>
-          <a:prstGeom prst="rect">
-            <a:avLst/>
-          </a:prstGeom>
-          <a:noFill/>
-        </p:spPr>
-        <p:txBody>
-          <a:bodyPr wrap="square">
-            <a:spAutoFit/>
-          </a:bodyPr>
-          <a:lstStyle/>
-          <a:p>
-            <a:pPr algn="l">
-              <a:lnSpc>
-                <a:spcPct val="125000"/>
-              </a:lnSpc>
-            </a:pPr>
-            <a:r>
-              <a:rPr sz="1200" b="0" i="0">
-                <a:solidFill>
-                  <a:srgbClr val="5A667A"/>
-                </a:solidFill>
-                <a:latin typeface="Segoe UI"/>
-              </a:rPr>
-              <a:t>The failure message now shows the model's actual reply. The bug that took three rounds to identify would have been obvious in one.</a:t>
+              <a:t>It exists for a hosted AI lane where the key stays server-side. Neither game needs it, which is why there is no server to operate or attack.</a:t>
             </a:r>
           </a:p>
         </p:txBody>
@@ -6806,7 +6524,7 @@
                 </a:solidFill>
                 <a:latin typeface="Segoe UI"/>
               </a:rPr>
-              <a:t>CREDITS</a:t>
+              <a:t>LOW-LEVEL DESIGN</a:t>
             </a:r>
           </a:p>
         </p:txBody>
@@ -6845,7 +6563,7 @@
                 </a:solidFill>
                 <a:latin typeface="Segoe UI"/>
               </a:rPr>
-              <a:t>Standing on other people's work</a:t>
+              <a:t>What each file is responsible for</a:t>
             </a:r>
           </a:p>
         </p:txBody>
@@ -6884,7 +6602,7 @@
                 </a:solidFill>
                 <a:latin typeface="Segoe UI"/>
               </a:rPr>
-              <a:t>MNIST-PRO  -  MIT</a:t>
+              <a:t>docs/js/mnistpro.js  -  746 lines</a:t>
             </a:r>
           </a:p>
         </p:txBody>
@@ -6923,7 +6641,7 @@
                 </a:solidFill>
                 <a:latin typeface="Segoe UI"/>
               </a:rPr>
-              <a:t>Toh, Majumder, Liu, Chen and Poria. DeCLaRe Lab, Nanyang Technological University, and A*STAR. arXiv:2608.31022  ·  github.com/declare-lab/MNIST-PRO</a:t>
+              <a:t>The MNIST-PRO client. Ports env.py: newLane, move, applyAction, and a REASON enum of answered / step_limit / invalid_action / stopped. Plus draw() mirroring render_observation, and the agent loop: runAi, callModel, extractJson, normaliseAction.</a:t>
             </a:r>
           </a:p>
         </p:txBody>
@@ -6936,7 +6654,7 @@
         </p:nvSpPr>
         <p:spPr>
           <a:xfrm>
-            <a:off x="868680" y="2663825"/>
+            <a:off x="868680" y="2581529"/>
             <a:ext cx="10607040" cy="246761"/>
           </a:xfrm>
           <a:prstGeom prst="rect">
@@ -6962,7 +6680,7 @@
                 </a:solidFill>
                 <a:latin typeface="Segoe UI"/>
               </a:rPr>
-              <a:t>MNIST  -  CC BY-SA 3.0</a:t>
+              <a:t>docs/js/game.js  -  971 lines</a:t>
             </a:r>
           </a:p>
         </p:txBody>
@@ -6975,7 +6693,7 @@
         </p:nvSpPr>
         <p:spPr>
           <a:xfrm>
-            <a:off x="868680" y="2947162"/>
+            <a:off x="868680" y="2864866"/>
             <a:ext cx="10607040" cy="207264"/>
           </a:xfrm>
           <a:prstGeom prst="rect">
@@ -7001,7 +6719,7 @@
                 </a:solidFill>
                 <a:latin typeface="Segoe UI"/>
               </a:rPr>
-              <a:t>LeCun, Cortes and Burges, derived from NIST Special Database 19.</a:t>
+              <a:t>The ARC client: grid editor, SHA-256 grading, five-minute clock, its own agent loop.</a:t>
             </a:r>
           </a:p>
         </p:txBody>
@@ -7014,7 +6732,7 @@
         </p:nvSpPr>
         <p:spPr>
           <a:xfrm>
-            <a:off x="868680" y="3337306"/>
+            <a:off x="868680" y="3172713"/>
             <a:ext cx="10607040" cy="246761"/>
           </a:xfrm>
           <a:prstGeom prst="rect">
@@ -7040,7 +6758,7 @@
                 </a:solidFill>
                 <a:latin typeface="Segoe UI"/>
               </a:rPr>
-              <a:t>ARC-AGI-1  -  Apache 2.0</a:t>
+              <a:t>docs/css/styles.css  -  1026 lines  ·  index.html, arc.html, guide.html</a:t>
             </a:r>
           </a:p>
         </p:txBody>
@@ -7053,7 +6771,7 @@
         </p:nvSpPr>
         <p:spPr>
           <a:xfrm>
-            <a:off x="868680" y="3620643"/>
+            <a:off x="868680" y="3456050"/>
             <a:ext cx="10607040" cy="207264"/>
           </a:xfrm>
           <a:prstGeom prst="rect">
@@ -7079,7 +6797,7 @@
                 </a:solidFill>
                 <a:latin typeface="Segoe UI"/>
               </a:rPr>
-              <a:t>Francois Chollet. The public training set, used unmodified.</a:t>
+              <a:t>One stylesheet for both games. No framework, no build step, no bundler.</a:t>
             </a:r>
           </a:p>
         </p:txBody>
@@ -7092,7 +6810,7 @@
         </p:nvSpPr>
         <p:spPr>
           <a:xfrm>
-            <a:off x="868680" y="4010787"/>
+            <a:off x="868680" y="3763899"/>
             <a:ext cx="10607040" cy="246761"/>
           </a:xfrm>
           <a:prstGeom prst="rect">
@@ -7118,7 +6836,7 @@
                 </a:solidFill>
                 <a:latin typeface="Segoe UI"/>
               </a:rPr>
-              <a:t>Licences are retained in the repository.</a:t>
+              <a:t>backend/app/  -  optional FastAPI service</a:t>
             </a:r>
           </a:p>
         </p:txBody>
@@ -7131,8 +6849,8 @@
         </p:nvSpPr>
         <p:spPr>
           <a:xfrm>
-            <a:off x="868680" y="4294124"/>
-            <a:ext cx="10607040" cy="207264"/>
+            <a:off x="868680" y="4047236"/>
+            <a:ext cx="10607040" cy="414528"/>
           </a:xfrm>
           <a:prstGeom prst="rect">
             <a:avLst/>
@@ -7157,7 +6875,7 @@
                 </a:solidFill>
                 <a:latin typeface="Segoe UI"/>
               </a:rPr>
-              <a:t>third_party/mnist-pro/LICENSE, with attribution files beside the generated data.</a:t>
+              <a:t>core/config.py holds the only secret; services/ has arc_service, session_manager and openrouter_agent; schemas/models.py validates every grid before it is trusted.</a:t>
             </a:r>
           </a:p>
         </p:txBody>
@@ -7195,7 +6913,7 @@
             <a:avLst/>
           </a:prstGeom>
           <a:solidFill>
-            <a:srgbClr val="0E1A2B"/>
+            <a:srgbClr val="FAFBFD"/>
           </a:solidFill>
           <a:ln>
             <a:noFill/>
@@ -7232,8 +6950,8 @@
         </p:nvSpPr>
         <p:spPr>
           <a:xfrm>
-            <a:off x="0" y="2697480"/>
-            <a:ext cx="12191695" cy="41148"/>
+            <a:off x="640080" y="566928"/>
+            <a:ext cx="82296" cy="420624"/>
           </a:xfrm>
           <a:prstGeom prst="rect">
             <a:avLst/>
@@ -7276,8 +6994,8 @@
         </p:nvSpPr>
         <p:spPr>
           <a:xfrm>
-            <a:off x="914400" y="1645920"/>
-            <a:ext cx="10515600" cy="822960"/>
+            <a:off x="868680" y="502920"/>
+            <a:ext cx="10058400" cy="310896"/>
           </a:xfrm>
           <a:prstGeom prst="rect">
             <a:avLst/>
@@ -7296,13 +7014,13 @@
               </a:lnSpc>
             </a:pPr>
             <a:r>
-              <a:rPr sz="3800" b="1" i="0">
-                <a:solidFill>
-                  <a:srgbClr val="FFFFFF"/>
-                </a:solidFill>
-                <a:latin typeface="Segoe UI"/>
-              </a:rPr>
-              <a:t>Play it</a:t>
+              <a:rPr sz="1100" b="1" i="0">
+                <a:solidFill>
+                  <a:srgbClr val="5A667A"/>
+                </a:solidFill>
+                <a:latin typeface="Segoe UI"/>
+              </a:rPr>
+              <a:t>LOW-LEVEL DESIGN</a:t>
             </a:r>
           </a:p>
         </p:txBody>
@@ -7315,81 +7033,33 @@
         </p:nvSpPr>
         <p:spPr>
           <a:xfrm>
-            <a:off x="914400" y="2971800"/>
-            <a:ext cx="10515600" cy="2194560"/>
-          </a:xfrm>
-          <a:prstGeom prst="rect">
-            <a:avLst/>
-          </a:prstGeom>
-          <a:noFill/>
-        </p:spPr>
-        <p:txBody>
-          <a:bodyPr wrap="square">
-            <a:spAutoFit/>
-          </a:bodyPr>
-          <a:lstStyle/>
-          <a:p>
-            <a:pPr algn="l">
-              <a:lnSpc>
-                <a:spcPct val="190000"/>
-              </a:lnSpc>
-            </a:pPr>
-            <a:r>
-              <a:rPr sz="1550" b="0" i="0">
-                <a:solidFill>
-                  <a:srgbClr val="D4DEEA"/>
-                </a:solidFill>
-                <a:latin typeface="Segoe UI"/>
-              </a:rPr>
-              <a:t>MNIST-PRO        panandi.github.io/mnistpro</a:t>
-            </a:r>
-          </a:p>
-          <a:p>
-            <a:pPr algn="l">
-              <a:lnSpc>
-                <a:spcPct val="190000"/>
-              </a:lnSpc>
-            </a:pPr>
-            <a:r>
-              <a:rPr sz="1550" b="0" i="0">
-                <a:solidFill>
-                  <a:srgbClr val="D4DEEA"/>
-                </a:solidFill>
-                <a:latin typeface="Segoe UI"/>
-              </a:rPr>
-              <a:t>ARC Race         panandi.github.io/mnistpro/arc.html</a:t>
-            </a:r>
-          </a:p>
-          <a:p>
-            <a:pPr algn="l">
-              <a:lnSpc>
-                <a:spcPct val="190000"/>
-              </a:lnSpc>
-            </a:pPr>
-            <a:r>
-              <a:rPr sz="1550" b="0" i="0">
-                <a:solidFill>
-                  <a:srgbClr val="D4DEEA"/>
-                </a:solidFill>
-                <a:latin typeface="Segoe UI"/>
-              </a:rPr>
-              <a:t>Player's guide   panandi.github.io/mnistpro/guide.html</a:t>
-            </a:r>
-          </a:p>
-          <a:p>
-            <a:pPr algn="l">
-              <a:lnSpc>
-                <a:spcPct val="190000"/>
-              </a:lnSpc>
-            </a:pPr>
-            <a:r>
-              <a:rPr sz="1550" b="0" i="0">
-                <a:solidFill>
-                  <a:srgbClr val="D4DEEA"/>
-                </a:solidFill>
-                <a:latin typeface="Segoe UI"/>
-              </a:rPr>
-              <a:t>Source           github.com/panandi/mnistpro</a:t>
+            <a:off x="841248" y="841248"/>
+            <a:ext cx="10607040" cy="566928"/>
+          </a:xfrm>
+          <a:prstGeom prst="rect">
+            <a:avLst/>
+          </a:prstGeom>
+          <a:noFill/>
+        </p:spPr>
+        <p:txBody>
+          <a:bodyPr wrap="square">
+            <a:spAutoFit/>
+          </a:bodyPr>
+          <a:lstStyle/>
+          <a:p>
+            <a:pPr algn="l">
+              <a:lnSpc>
+                <a:spcPct val="115000"/>
+              </a:lnSpc>
+            </a:pPr>
+            <a:r>
+              <a:rPr sz="2800" b="1" i="0">
+                <a:solidFill>
+                  <a:srgbClr val="141B2D"/>
+                </a:solidFill>
+                <a:latin typeface="Segoe UI"/>
+              </a:rPr>
+              <a:t>One AI step, end to end</a:t>
             </a:r>
           </a:p>
         </p:txBody>
@@ -7402,8 +7072,8 @@
         </p:nvSpPr>
         <p:spPr>
           <a:xfrm>
-            <a:off x="914400" y="5715000"/>
-            <a:ext cx="10515600" cy="548640"/>
+            <a:off x="868680" y="1783080"/>
+            <a:ext cx="10607040" cy="246761"/>
           </a:xfrm>
           <a:prstGeom prst="rect">
             <a:avLst/>
@@ -7422,13 +7092,286 @@
               </a:lnSpc>
             </a:pPr>
             <a:r>
-              <a:rPr sz="1300" b="0" i="0">
-                <a:solidFill>
-                  <a:srgbClr val="8D9DB2"/>
-                </a:solidFill>
-                <a:latin typeface="Segoe UI"/>
-              </a:rPr>
-              <a:t>No install, no sign-up, no key needed to play solo. Bring an OpenRouter key if you want to race the model.</a:t>
+              <a:rPr sz="1450" b="1" i="0">
+                <a:solidFill>
+                  <a:srgbClr val="141B2D"/>
+                </a:solidFill>
+                <a:latin typeface="Segoe UI"/>
+              </a:rPr>
+              <a:t>1.  Render the observation.</a:t>
+            </a:r>
+          </a:p>
+        </p:txBody>
+      </p:sp>
+      <p:sp>
+        <p:nvSpPr>
+          <p:cNvPr id="7" name="TextBox 6"/>
+          <p:cNvSpPr txBox="1"/>
+          <p:nvPr/>
+        </p:nvSpPr>
+        <p:spPr>
+          <a:xfrm>
+            <a:off x="868680" y="2066416"/>
+            <a:ext cx="10607040" cy="414528"/>
+          </a:xfrm>
+          <a:prstGeom prst="rect">
+            <a:avLst/>
+          </a:prstGeom>
+          <a:noFill/>
+        </p:spPr>
+        <p:txBody>
+          <a:bodyPr wrap="square">
+            <a:spAutoFit/>
+          </a:bodyPr>
+          <a:lstStyle/>
+          <a:p>
+            <a:pPr algn="l">
+              <a:lnSpc>
+                <a:spcPct val="125000"/>
+              </a:lnSpc>
+            </a:pPr>
+            <a:r>
+              <a:rPr sz="1200" b="0" i="0">
+                <a:solidFill>
+                  <a:srgbClr val="5A667A"/>
+                </a:solidFill>
+                <a:latin typeface="Segoe UI"/>
+              </a:rPr>
+              <a:t>draw() fills the canvas grey, pastes the 64px window from the unpacked bitmap and strokes the cyan border - the same masking render_observation performs. observationPng() forces a single window even when the spectator view shows a trail.</a:t>
+            </a:r>
+          </a:p>
+        </p:txBody>
+      </p:sp>
+      <p:sp>
+        <p:nvSpPr>
+          <p:cNvPr id="8" name="TextBox 7"/>
+          <p:cNvSpPr txBox="1"/>
+          <p:nvPr/>
+        </p:nvSpPr>
+        <p:spPr>
+          <a:xfrm>
+            <a:off x="868680" y="2572385"/>
+            <a:ext cx="10607040" cy="246761"/>
+          </a:xfrm>
+          <a:prstGeom prst="rect">
+            <a:avLst/>
+          </a:prstGeom>
+          <a:noFill/>
+        </p:spPr>
+        <p:txBody>
+          <a:bodyPr wrap="square">
+            <a:spAutoFit/>
+          </a:bodyPr>
+          <a:lstStyle/>
+          <a:p>
+            <a:pPr algn="l">
+              <a:lnSpc>
+                <a:spcPct val="115000"/>
+              </a:lnSpc>
+            </a:pPr>
+            <a:r>
+              <a:rPr sz="1450" b="1" i="0">
+                <a:solidFill>
+                  <a:srgbClr val="141B2D"/>
+                </a:solidFill>
+                <a:latin typeface="Segoe UI"/>
+              </a:rPr>
+              <a:t>2.  Ask the model.</a:t>
+            </a:r>
+          </a:p>
+        </p:txBody>
+      </p:sp>
+      <p:sp>
+        <p:nvSpPr>
+          <p:cNvPr id="9" name="TextBox 8"/>
+          <p:cNvSpPr txBox="1"/>
+          <p:nvPr/>
+        </p:nvSpPr>
+        <p:spPr>
+          <a:xfrm>
+            <a:off x="868680" y="2855722"/>
+            <a:ext cx="10607040" cy="414528"/>
+          </a:xfrm>
+          <a:prstGeom prst="rect">
+            <a:avLst/>
+          </a:prstGeom>
+          <a:noFill/>
+        </p:spPr>
+        <p:txBody>
+          <a:bodyPr wrap="square">
+            <a:spAutoFit/>
+          </a:bodyPr>
+          <a:lstStyle/>
+          <a:p>
+            <a:pPr algn="l">
+              <a:lnSpc>
+                <a:spcPct val="125000"/>
+              </a:lnSpc>
+            </a:pPr>
+            <a:r>
+              <a:rPr sz="1200" b="0" i="0">
+                <a:solidFill>
+                  <a:srgbClr val="5A667A"/>
+                </a:solidFill>
+                <a:latin typeface="Segoe UI"/>
+              </a:rPr>
+              <a:t>callModel posts the PNG plus the transcript, max_tokens 2000, and reads finish_reason. A truncated reply is retried with double the budget rather than repeated unchanged.</a:t>
+            </a:r>
+          </a:p>
+        </p:txBody>
+      </p:sp>
+      <p:sp>
+        <p:nvSpPr>
+          <p:cNvPr id="10" name="TextBox 9"/>
+          <p:cNvSpPr txBox="1"/>
+          <p:nvPr/>
+        </p:nvSpPr>
+        <p:spPr>
+          <a:xfrm>
+            <a:off x="868680" y="3361690"/>
+            <a:ext cx="10607040" cy="246761"/>
+          </a:xfrm>
+          <a:prstGeom prst="rect">
+            <a:avLst/>
+          </a:prstGeom>
+          <a:noFill/>
+        </p:spPr>
+        <p:txBody>
+          <a:bodyPr wrap="square">
+            <a:spAutoFit/>
+          </a:bodyPr>
+          <a:lstStyle/>
+          <a:p>
+            <a:pPr algn="l">
+              <a:lnSpc>
+                <a:spcPct val="115000"/>
+              </a:lnSpc>
+            </a:pPr>
+            <a:r>
+              <a:rPr sz="1450" b="1" i="0">
+                <a:solidFill>
+                  <a:srgbClr val="141B2D"/>
+                </a:solidFill>
+                <a:latin typeface="Segoe UI"/>
+              </a:rPr>
+              <a:t>3.  Read the action.</a:t>
+            </a:r>
+          </a:p>
+        </p:txBody>
+      </p:sp>
+      <p:sp>
+        <p:nvSpPr>
+          <p:cNvPr id="11" name="TextBox 10"/>
+          <p:cNvSpPr txBox="1"/>
+          <p:nvPr/>
+        </p:nvSpPr>
+        <p:spPr>
+          <a:xfrm>
+            <a:off x="868680" y="3645027"/>
+            <a:ext cx="10607040" cy="414528"/>
+          </a:xfrm>
+          <a:prstGeom prst="rect">
+            <a:avLst/>
+          </a:prstGeom>
+          <a:noFill/>
+        </p:spPr>
+        <p:txBody>
+          <a:bodyPr wrap="square">
+            <a:spAutoFit/>
+          </a:bodyPr>
+          <a:lstStyle/>
+          <a:p>
+            <a:pPr algn="l">
+              <a:lnSpc>
+                <a:spcPct val="125000"/>
+              </a:lnSpc>
+            </a:pPr>
+            <a:r>
+              <a:rPr sz="1200" b="0" i="0">
+                <a:solidFill>
+                  <a:srgbClr val="5A667A"/>
+                </a:solidFill>
+                <a:latin typeface="Segoe UI"/>
+              </a:rPr>
+              <a:t>extractJson strips code fences and scans every balanced object, preferring the last one that names an action. normaliseAction trims and lowercases it, so "Right." is honoured - an unrecognised verb still ends the episode, as the benchmark intends.</a:t>
+            </a:r>
+          </a:p>
+        </p:txBody>
+      </p:sp>
+      <p:sp>
+        <p:nvSpPr>
+          <p:cNvPr id="12" name="TextBox 11"/>
+          <p:cNvSpPr txBox="1"/>
+          <p:nvPr/>
+        </p:nvSpPr>
+        <p:spPr>
+          <a:xfrm>
+            <a:off x="868680" y="4150995"/>
+            <a:ext cx="10607040" cy="246761"/>
+          </a:xfrm>
+          <a:prstGeom prst="rect">
+            <a:avLst/>
+          </a:prstGeom>
+          <a:noFill/>
+        </p:spPr>
+        <p:txBody>
+          <a:bodyPr wrap="square">
+            <a:spAutoFit/>
+          </a:bodyPr>
+          <a:lstStyle/>
+          <a:p>
+            <a:pPr algn="l">
+              <a:lnSpc>
+                <a:spcPct val="115000"/>
+              </a:lnSpc>
+            </a:pPr>
+            <a:r>
+              <a:rPr sz="1450" b="1" i="0">
+                <a:solidFill>
+                  <a:srgbClr val="141B2D"/>
+                </a:solidFill>
+                <a:latin typeface="Segoe UI"/>
+              </a:rPr>
+              <a:t>4.  Apply it, or refuse and say why.</a:t>
+            </a:r>
+          </a:p>
+        </p:txBody>
+      </p:sp>
+      <p:sp>
+        <p:nvSpPr>
+          <p:cNvPr id="13" name="TextBox 12"/>
+          <p:cNvSpPr txBox="1"/>
+          <p:nvPr/>
+        </p:nvSpPr>
+        <p:spPr>
+          <a:xfrm>
+            <a:off x="868680" y="4434332"/>
+            <a:ext cx="10607040" cy="207264"/>
+          </a:xfrm>
+          <a:prstGeom prst="rect">
+            <a:avLst/>
+          </a:prstGeom>
+          <a:noFill/>
+        </p:spPr>
+        <p:txBody>
+          <a:bodyPr wrap="square">
+            <a:spAutoFit/>
+          </a:bodyPr>
+          <a:lstStyle/>
+          <a:p>
+            <a:pPr algn="l">
+              <a:lnSpc>
+                <a:spcPct val="125000"/>
+              </a:lnSpc>
+            </a:pPr>
+            <a:r>
+              <a:rPr sz="1200" b="0" i="0">
+                <a:solidFill>
+                  <a:srgbClr val="5A667A"/>
+                </a:solidFill>
+                <a:latin typeface="Segoe UI"/>
+              </a:rPr>
+              <a:t>applyAction reports whether it applied. A reply arriving after the round ended is discarded and logged rather than scored.</a:t>
             </a:r>
           </a:p>
         </p:txBody>
@@ -7886,6 +7829,2757 @@
                 <a:latin typeface="Segoe UI"/>
               </a:rPr>
               <a:t>Passive perception is not active perception. A model that reads an image perfectly can still be poor at deciding what to look at.</a:t>
+            </a:r>
+          </a:p>
+        </p:txBody>
+      </p:sp>
+    </p:spTree>
+  </p:cSld>
+  <p:clrMapOvr>
+    <a:masterClrMapping/>
+  </p:clrMapOvr>
+</p:sld>
+</file>
+
+<file path=ppt/slides/slide20.xml><?xml version="1.0" encoding="utf-8"?>
+<p:sld xmlns:a="http://schemas.openxmlformats.org/drawingml/2006/main" xmlns:p="http://schemas.openxmlformats.org/presentationml/2006/main" xmlns:r="http://schemas.openxmlformats.org/officeDocument/2006/relationships">
+  <p:cSld>
+    <p:spTree>
+      <p:nvGrpSpPr>
+        <p:cNvPr id="1" name=""/>
+        <p:cNvGrpSpPr/>
+        <p:nvPr/>
+      </p:nvGrpSpPr>
+      <p:grpSpPr/>
+      <p:sp>
+        <p:nvSpPr>
+          <p:cNvPr id="2" name="Rectangle 1"/>
+          <p:cNvSpPr/>
+          <p:nvPr/>
+        </p:nvSpPr>
+        <p:spPr>
+          <a:xfrm>
+            <a:off x="0" y="0"/>
+            <a:ext cx="12191695" cy="6858000"/>
+          </a:xfrm>
+          <a:prstGeom prst="rect">
+            <a:avLst/>
+          </a:prstGeom>
+          <a:solidFill>
+            <a:srgbClr val="FAFBFD"/>
+          </a:solidFill>
+          <a:ln>
+            <a:noFill/>
+          </a:ln>
+          <a:effectLst/>
+        </p:spPr>
+        <p:style>
+          <a:lnRef idx="1">
+            <a:schemeClr val="accent1"/>
+          </a:lnRef>
+          <a:fillRef idx="3">
+            <a:schemeClr val="accent1"/>
+          </a:fillRef>
+          <a:effectRef idx="2">
+            <a:schemeClr val="accent1"/>
+          </a:effectRef>
+          <a:fontRef idx="minor">
+            <a:schemeClr val="lt1"/>
+          </a:fontRef>
+        </p:style>
+        <p:txBody>
+          <a:bodyPr rtlCol="0" anchor="ctr"/>
+          <a:lstStyle/>
+          <a:p>
+            <a:pPr algn="ctr"/>
+          </a:p>
+        </p:txBody>
+      </p:sp>
+      <p:sp>
+        <p:nvSpPr>
+          <p:cNvPr id="3" name="Rectangle 2"/>
+          <p:cNvSpPr/>
+          <p:nvPr/>
+        </p:nvSpPr>
+        <p:spPr>
+          <a:xfrm>
+            <a:off x="640080" y="566928"/>
+            <a:ext cx="82296" cy="420624"/>
+          </a:xfrm>
+          <a:prstGeom prst="rect">
+            <a:avLst/>
+          </a:prstGeom>
+          <a:solidFill>
+            <a:srgbClr val="00A8BF"/>
+          </a:solidFill>
+          <a:ln>
+            <a:noFill/>
+          </a:ln>
+          <a:effectLst/>
+        </p:spPr>
+        <p:style>
+          <a:lnRef idx="1">
+            <a:schemeClr val="accent1"/>
+          </a:lnRef>
+          <a:fillRef idx="3">
+            <a:schemeClr val="accent1"/>
+          </a:fillRef>
+          <a:effectRef idx="2">
+            <a:schemeClr val="accent1"/>
+          </a:effectRef>
+          <a:fontRef idx="minor">
+            <a:schemeClr val="lt1"/>
+          </a:fontRef>
+        </p:style>
+        <p:txBody>
+          <a:bodyPr rtlCol="0" anchor="ctr"/>
+          <a:lstStyle/>
+          <a:p>
+            <a:pPr algn="ctr"/>
+          </a:p>
+        </p:txBody>
+      </p:sp>
+      <p:sp>
+        <p:nvSpPr>
+          <p:cNvPr id="4" name="TextBox 3"/>
+          <p:cNvSpPr txBox="1"/>
+          <p:nvPr/>
+        </p:nvSpPr>
+        <p:spPr>
+          <a:xfrm>
+            <a:off x="868680" y="502920"/>
+            <a:ext cx="10058400" cy="310896"/>
+          </a:xfrm>
+          <a:prstGeom prst="rect">
+            <a:avLst/>
+          </a:prstGeom>
+          <a:noFill/>
+        </p:spPr>
+        <p:txBody>
+          <a:bodyPr wrap="square">
+            <a:spAutoFit/>
+          </a:bodyPr>
+          <a:lstStyle/>
+          <a:p>
+            <a:pPr algn="l">
+              <a:lnSpc>
+                <a:spcPct val="115000"/>
+              </a:lnSpc>
+            </a:pPr>
+            <a:r>
+              <a:rPr sz="1100" b="1" i="0">
+                <a:solidFill>
+                  <a:srgbClr val="5A667A"/>
+                </a:solidFill>
+                <a:latin typeface="Segoe UI"/>
+              </a:rPr>
+              <a:t>LOW-LEVEL DESIGN</a:t>
+            </a:r>
+          </a:p>
+        </p:txBody>
+      </p:sp>
+      <p:sp>
+        <p:nvSpPr>
+          <p:cNvPr id="5" name="TextBox 4"/>
+          <p:cNvSpPr txBox="1"/>
+          <p:nvPr/>
+        </p:nvSpPr>
+        <p:spPr>
+          <a:xfrm>
+            <a:off x="841248" y="841248"/>
+            <a:ext cx="10607040" cy="566928"/>
+          </a:xfrm>
+          <a:prstGeom prst="rect">
+            <a:avLst/>
+          </a:prstGeom>
+          <a:noFill/>
+        </p:spPr>
+        <p:txBody>
+          <a:bodyPr wrap="square">
+            <a:spAutoFit/>
+          </a:bodyPr>
+          <a:lstStyle/>
+          <a:p>
+            <a:pPr algn="l">
+              <a:lnSpc>
+                <a:spcPct val="115000"/>
+              </a:lnSpc>
+            </a:pPr>
+            <a:r>
+              <a:rPr sz="2800" b="1" i="0">
+                <a:solidFill>
+                  <a:srgbClr val="141B2D"/>
+                </a:solidFill>
+                <a:latin typeface="Segoe UI"/>
+              </a:rPr>
+              <a:t>The two data contracts</a:t>
+            </a:r>
+          </a:p>
+        </p:txBody>
+      </p:sp>
+      <p:sp>
+        <p:nvSpPr>
+          <p:cNvPr id="6" name="TextBox 5"/>
+          <p:cNvSpPr txBox="1"/>
+          <p:nvPr/>
+        </p:nvSpPr>
+        <p:spPr>
+          <a:xfrm>
+            <a:off x="868680" y="1783080"/>
+            <a:ext cx="10607040" cy="246761"/>
+          </a:xfrm>
+          <a:prstGeom prst="rect">
+            <a:avLst/>
+          </a:prstGeom>
+          <a:noFill/>
+        </p:spPr>
+        <p:txBody>
+          <a:bodyPr wrap="square">
+            <a:spAutoFit/>
+          </a:bodyPr>
+          <a:lstStyle/>
+          <a:p>
+            <a:pPr algn="l">
+              <a:lnSpc>
+                <a:spcPct val="115000"/>
+              </a:lnSpc>
+            </a:pPr>
+            <a:r>
+              <a:rPr sz="1450" b="1" i="0">
+                <a:solidFill>
+                  <a:srgbClr val="141B2D"/>
+                </a:solidFill>
+                <a:latin typeface="Segoe UI"/>
+              </a:rPr>
+              <a:t>MNIST-PRO episode  -  data/mnistpro/episodes/epNNN.json</a:t>
+            </a:r>
+          </a:p>
+        </p:txBody>
+      </p:sp>
+      <p:sp>
+        <p:nvSpPr>
+          <p:cNvPr id="7" name="TextBox 6"/>
+          <p:cNvSpPr txBox="1"/>
+          <p:nvPr/>
+        </p:nvSpPr>
+        <p:spPr>
+          <a:xfrm>
+            <a:off x="868680" y="2066416"/>
+            <a:ext cx="10607040" cy="414528"/>
+          </a:xfrm>
+          <a:prstGeom prst="rect">
+            <a:avLst/>
+          </a:prstGeom>
+          <a:noFill/>
+        </p:spPr>
+        <p:txBody>
+          <a:bodyPr wrap="square">
+            <a:spAutoFit/>
+          </a:bodyPr>
+          <a:lstStyle/>
+          <a:p>
+            <a:pPr algn="l">
+              <a:lnSpc>
+                <a:spcPct val="125000"/>
+              </a:lnSpc>
+            </a:pPr>
+            <a:r>
+              <a:rPr sz="1200" b="0" i="0">
+                <a:solidFill>
+                  <a:srgbClr val="5A667A"/>
+                </a:solidFill>
+                <a:latin typeface="Segoe UI"/>
+              </a:rPr>
+              <a:t>id, label, source_index, width 224, height 224, box_size 64, step_size 32, max_steps 36, start [x,y], and bits: the stroke bitmap packed one pixel per bit as base64. 200 episodes, 2.5 MB, gzipped to a few hundred bytes each in transit.</a:t>
+            </a:r>
+          </a:p>
+        </p:txBody>
+      </p:sp>
+      <p:sp>
+        <p:nvSpPr>
+          <p:cNvPr id="8" name="TextBox 7"/>
+          <p:cNvSpPr txBox="1"/>
+          <p:nvPr/>
+        </p:nvSpPr>
+        <p:spPr>
+          <a:xfrm>
+            <a:off x="868680" y="2581529"/>
+            <a:ext cx="10607040" cy="246761"/>
+          </a:xfrm>
+          <a:prstGeom prst="rect">
+            <a:avLst/>
+          </a:prstGeom>
+          <a:noFill/>
+        </p:spPr>
+        <p:txBody>
+          <a:bodyPr wrap="square">
+            <a:spAutoFit/>
+          </a:bodyPr>
+          <a:lstStyle/>
+          <a:p>
+            <a:pPr algn="l">
+              <a:lnSpc>
+                <a:spcPct val="115000"/>
+              </a:lnSpc>
+            </a:pPr>
+            <a:r>
+              <a:rPr sz="1450" b="1" i="0">
+                <a:solidFill>
+                  <a:srgbClr val="141B2D"/>
+                </a:solidFill>
+                <a:latin typeface="Segoe UI"/>
+              </a:rPr>
+              <a:t>ARC task  -  data/tasks/&lt;id&gt;.json</a:t>
+            </a:r>
+          </a:p>
+        </p:txBody>
+      </p:sp>
+      <p:sp>
+        <p:nvSpPr>
+          <p:cNvPr id="9" name="TextBox 8"/>
+          <p:cNvSpPr txBox="1"/>
+          <p:nvPr/>
+        </p:nvSpPr>
+        <p:spPr>
+          <a:xfrm>
+            <a:off x="868680" y="2864866"/>
+            <a:ext cx="10607040" cy="414528"/>
+          </a:xfrm>
+          <a:prstGeom prst="rect">
+            <a:avLst/>
+          </a:prstGeom>
+          <a:noFill/>
+        </p:spPr>
+        <p:txBody>
+          <a:bodyPr wrap="square">
+            <a:spAutoFit/>
+          </a:bodyPr>
+          <a:lstStyle/>
+          <a:p>
+            <a:pPr algn="l">
+              <a:lnSpc>
+                <a:spcPct val="125000"/>
+              </a:lnSpc>
+            </a:pPr>
+            <a:r>
+              <a:rPr sz="1200" b="0" i="0">
+                <a:solidFill>
+                  <a:srgbClr val="5A667A"/>
+                </a:solidFill>
+                <a:latin typeface="Segoe UI"/>
+              </a:rPr>
+              <a:t>id, train, test_input, answer_sha256, answer_rows, answer_cols, and for the easy tier a tier and hint. The answer itself is never present. 386 tasks, 1.4 MB.</a:t>
+            </a:r>
+          </a:p>
+        </p:txBody>
+      </p:sp>
+      <p:sp>
+        <p:nvSpPr>
+          <p:cNvPr id="10" name="TextBox 9"/>
+          <p:cNvSpPr txBox="1"/>
+          <p:nvPr/>
+        </p:nvSpPr>
+        <p:spPr>
+          <a:xfrm>
+            <a:off x="868680" y="3379978"/>
+            <a:ext cx="10607040" cy="246761"/>
+          </a:xfrm>
+          <a:prstGeom prst="rect">
+            <a:avLst/>
+          </a:prstGeom>
+          <a:noFill/>
+        </p:spPr>
+        <p:txBody>
+          <a:bodyPr wrap="square">
+            <a:spAutoFit/>
+          </a:bodyPr>
+          <a:lstStyle/>
+          <a:p>
+            <a:pPr algn="l">
+              <a:lnSpc>
+                <a:spcPct val="115000"/>
+              </a:lnSpc>
+            </a:pPr>
+            <a:r>
+              <a:rPr sz="1450" b="1" i="0">
+                <a:solidFill>
+                  <a:srgbClr val="141B2D"/>
+                </a:solidFill>
+                <a:latin typeface="Segoe UI"/>
+              </a:rPr>
+              <a:t>Grading is a hash comparison, not a lookup.</a:t>
+            </a:r>
+          </a:p>
+        </p:txBody>
+      </p:sp>
+      <p:sp>
+        <p:nvSpPr>
+          <p:cNvPr id="11" name="TextBox 10"/>
+          <p:cNvSpPr txBox="1"/>
+          <p:nvPr/>
+        </p:nvSpPr>
+        <p:spPr>
+          <a:xfrm>
+            <a:off x="868680" y="3663314"/>
+            <a:ext cx="10607040" cy="207264"/>
+          </a:xfrm>
+          <a:prstGeom prst="rect">
+            <a:avLst/>
+          </a:prstGeom>
+          <a:noFill/>
+        </p:spPr>
+        <p:txBody>
+          <a:bodyPr wrap="square">
+            <a:spAutoFit/>
+          </a:bodyPr>
+          <a:lstStyle/>
+          <a:p>
+            <a:pPr algn="l">
+              <a:lnSpc>
+                <a:spcPct val="125000"/>
+              </a:lnSpc>
+            </a:pPr>
+            <a:r>
+              <a:rPr sz="1200" b="0" i="0">
+                <a:solidFill>
+                  <a:srgbClr val="5A667A"/>
+                </a:solidFill>
+                <a:latin typeface="Segoe UI"/>
+              </a:rPr>
+              <a:t>The browser hashes the submitted grid and compares digests, so a correct answer is recognised without the answer being in the page.</a:t>
+            </a:r>
+          </a:p>
+        </p:txBody>
+      </p:sp>
+      <p:sp>
+        <p:nvSpPr>
+          <p:cNvPr id="12" name="TextBox 11"/>
+          <p:cNvSpPr txBox="1"/>
+          <p:nvPr/>
+        </p:nvSpPr>
+        <p:spPr>
+          <a:xfrm>
+            <a:off x="868680" y="3971163"/>
+            <a:ext cx="10607040" cy="246761"/>
+          </a:xfrm>
+          <a:prstGeom prst="rect">
+            <a:avLst/>
+          </a:prstGeom>
+          <a:noFill/>
+        </p:spPr>
+        <p:txBody>
+          <a:bodyPr wrap="square">
+            <a:spAutoFit/>
+          </a:bodyPr>
+          <a:lstStyle/>
+          <a:p>
+            <a:pPr algn="l">
+              <a:lnSpc>
+                <a:spcPct val="115000"/>
+              </a:lnSpc>
+            </a:pPr>
+            <a:r>
+              <a:rPr sz="1450" b="1" i="0">
+                <a:solidFill>
+                  <a:srgbClr val="141B2D"/>
+                </a:solidFill>
+                <a:latin typeface="Segoe UI"/>
+              </a:rPr>
+              <a:t>Episode ids are the benchmark's own.</a:t>
+            </a:r>
+          </a:p>
+        </p:txBody>
+      </p:sp>
+      <p:sp>
+        <p:nvSpPr>
+          <p:cNvPr id="13" name="TextBox 12"/>
+          <p:cNvSpPr txBox="1"/>
+          <p:nvPr/>
+        </p:nvSpPr>
+        <p:spPr>
+          <a:xfrm>
+            <a:off x="868680" y="4254500"/>
+            <a:ext cx="10607040" cy="207264"/>
+          </a:xfrm>
+          <a:prstGeom prst="rect">
+            <a:avLst/>
+          </a:prstGeom>
+          <a:noFill/>
+        </p:spPr>
+        <p:txBody>
+          <a:bodyPr wrap="square">
+            <a:spAutoFit/>
+          </a:bodyPr>
+          <a:lstStyle/>
+          <a:p>
+            <a:pPr algn="l">
+              <a:lnSpc>
+                <a:spcPct val="125000"/>
+              </a:lnSpc>
+            </a:pPr>
+            <a:r>
+              <a:rPr sz="1200" b="0" i="0">
+                <a:solidFill>
+                  <a:srgbClr val="5A667A"/>
+                </a:solidFill>
+                <a:latin typeface="Segoe UI"/>
+              </a:rPr>
+              <a:t>Sampled with its sample_balanced at seed 42, so episode 0 here is episode 0 of the published runs - checked against their golden manifest.</a:t>
+            </a:r>
+          </a:p>
+        </p:txBody>
+      </p:sp>
+    </p:spTree>
+  </p:cSld>
+  <p:clrMapOvr>
+    <a:masterClrMapping/>
+  </p:clrMapOvr>
+</p:sld>
+</file>
+
+<file path=ppt/slides/slide21.xml><?xml version="1.0" encoding="utf-8"?>
+<p:sld xmlns:a="http://schemas.openxmlformats.org/drawingml/2006/main" xmlns:p="http://schemas.openxmlformats.org/presentationml/2006/main" xmlns:r="http://schemas.openxmlformats.org/officeDocument/2006/relationships">
+  <p:cSld>
+    <p:spTree>
+      <p:nvGrpSpPr>
+        <p:cNvPr id="1" name=""/>
+        <p:cNvGrpSpPr/>
+        <p:nvPr/>
+      </p:nvGrpSpPr>
+      <p:grpSpPr/>
+      <p:sp>
+        <p:nvSpPr>
+          <p:cNvPr id="2" name="Rectangle 1"/>
+          <p:cNvSpPr/>
+          <p:nvPr/>
+        </p:nvSpPr>
+        <p:spPr>
+          <a:xfrm>
+            <a:off x="0" y="0"/>
+            <a:ext cx="12191695" cy="6858000"/>
+          </a:xfrm>
+          <a:prstGeom prst="rect">
+            <a:avLst/>
+          </a:prstGeom>
+          <a:solidFill>
+            <a:srgbClr val="FAFBFD"/>
+          </a:solidFill>
+          <a:ln>
+            <a:noFill/>
+          </a:ln>
+          <a:effectLst/>
+        </p:spPr>
+        <p:style>
+          <a:lnRef idx="1">
+            <a:schemeClr val="accent1"/>
+          </a:lnRef>
+          <a:fillRef idx="3">
+            <a:schemeClr val="accent1"/>
+          </a:fillRef>
+          <a:effectRef idx="2">
+            <a:schemeClr val="accent1"/>
+          </a:effectRef>
+          <a:fontRef idx="minor">
+            <a:schemeClr val="lt1"/>
+          </a:fontRef>
+        </p:style>
+        <p:txBody>
+          <a:bodyPr rtlCol="0" anchor="ctr"/>
+          <a:lstStyle/>
+          <a:p>
+            <a:pPr algn="ctr"/>
+          </a:p>
+        </p:txBody>
+      </p:sp>
+      <p:sp>
+        <p:nvSpPr>
+          <p:cNvPr id="3" name="Rectangle 2"/>
+          <p:cNvSpPr/>
+          <p:nvPr/>
+        </p:nvSpPr>
+        <p:spPr>
+          <a:xfrm>
+            <a:off x="640080" y="566928"/>
+            <a:ext cx="82296" cy="420624"/>
+          </a:xfrm>
+          <a:prstGeom prst="rect">
+            <a:avLst/>
+          </a:prstGeom>
+          <a:solidFill>
+            <a:srgbClr val="00A8BF"/>
+          </a:solidFill>
+          <a:ln>
+            <a:noFill/>
+          </a:ln>
+          <a:effectLst/>
+        </p:spPr>
+        <p:style>
+          <a:lnRef idx="1">
+            <a:schemeClr val="accent1"/>
+          </a:lnRef>
+          <a:fillRef idx="3">
+            <a:schemeClr val="accent1"/>
+          </a:fillRef>
+          <a:effectRef idx="2">
+            <a:schemeClr val="accent1"/>
+          </a:effectRef>
+          <a:fontRef idx="minor">
+            <a:schemeClr val="lt1"/>
+          </a:fontRef>
+        </p:style>
+        <p:txBody>
+          <a:bodyPr rtlCol="0" anchor="ctr"/>
+          <a:lstStyle/>
+          <a:p>
+            <a:pPr algn="ctr"/>
+          </a:p>
+        </p:txBody>
+      </p:sp>
+      <p:sp>
+        <p:nvSpPr>
+          <p:cNvPr id="4" name="TextBox 3"/>
+          <p:cNvSpPr txBox="1"/>
+          <p:nvPr/>
+        </p:nvSpPr>
+        <p:spPr>
+          <a:xfrm>
+            <a:off x="868680" y="502920"/>
+            <a:ext cx="10058400" cy="310896"/>
+          </a:xfrm>
+          <a:prstGeom prst="rect">
+            <a:avLst/>
+          </a:prstGeom>
+          <a:noFill/>
+        </p:spPr>
+        <p:txBody>
+          <a:bodyPr wrap="square">
+            <a:spAutoFit/>
+          </a:bodyPr>
+          <a:lstStyle/>
+          <a:p>
+            <a:pPr algn="l">
+              <a:lnSpc>
+                <a:spcPct val="115000"/>
+              </a:lnSpc>
+            </a:pPr>
+            <a:r>
+              <a:rPr sz="1100" b="1" i="0">
+                <a:solidFill>
+                  <a:srgbClr val="5A667A"/>
+                </a:solidFill>
+                <a:latin typeface="Segoe UI"/>
+              </a:rPr>
+              <a:t>LOW-LEVEL DESIGN</a:t>
+            </a:r>
+          </a:p>
+        </p:txBody>
+      </p:sp>
+      <p:sp>
+        <p:nvSpPr>
+          <p:cNvPr id="5" name="TextBox 4"/>
+          <p:cNvSpPr txBox="1"/>
+          <p:nvPr/>
+        </p:nvSpPr>
+        <p:spPr>
+          <a:xfrm>
+            <a:off x="841248" y="841248"/>
+            <a:ext cx="10607040" cy="566928"/>
+          </a:xfrm>
+          <a:prstGeom prst="rect">
+            <a:avLst/>
+          </a:prstGeom>
+          <a:noFill/>
+        </p:spPr>
+        <p:txBody>
+          <a:bodyPr wrap="square">
+            <a:spAutoFit/>
+          </a:bodyPr>
+          <a:lstStyle/>
+          <a:p>
+            <a:pPr algn="l">
+              <a:lnSpc>
+                <a:spcPct val="115000"/>
+              </a:lnSpc>
+            </a:pPr>
+            <a:r>
+              <a:rPr sz="2800" b="1" i="0">
+                <a:solidFill>
+                  <a:srgbClr val="141B2D"/>
+                </a:solidFill>
+                <a:latin typeface="Segoe UI"/>
+              </a:rPr>
+              <a:t>How a lane can end, and who decides</a:t>
+            </a:r>
+          </a:p>
+        </p:txBody>
+      </p:sp>
+      <p:sp>
+        <p:nvSpPr>
+          <p:cNvPr id="6" name="TextBox 5"/>
+          <p:cNvSpPr txBox="1"/>
+          <p:nvPr/>
+        </p:nvSpPr>
+        <p:spPr>
+          <a:xfrm>
+            <a:off x="868680" y="1783080"/>
+            <a:ext cx="10607040" cy="246761"/>
+          </a:xfrm>
+          <a:prstGeom prst="rect">
+            <a:avLst/>
+          </a:prstGeom>
+          <a:noFill/>
+        </p:spPr>
+        <p:txBody>
+          <a:bodyPr wrap="square">
+            <a:spAutoFit/>
+          </a:bodyPr>
+          <a:lstStyle/>
+          <a:p>
+            <a:pPr algn="l">
+              <a:lnSpc>
+                <a:spcPct val="115000"/>
+              </a:lnSpc>
+            </a:pPr>
+            <a:r>
+              <a:rPr sz="1450" b="1" i="0">
+                <a:solidFill>
+                  <a:srgbClr val="141B2D"/>
+                </a:solidFill>
+                <a:latin typeface="Segoe UI"/>
+              </a:rPr>
+              <a:t>answered  -  the only outcome that can win.</a:t>
+            </a:r>
+          </a:p>
+        </p:txBody>
+      </p:sp>
+      <p:sp>
+        <p:nvSpPr>
+          <p:cNvPr id="7" name="TextBox 6"/>
+          <p:cNvSpPr txBox="1"/>
+          <p:nvPr/>
+        </p:nvSpPr>
+        <p:spPr>
+          <a:xfrm>
+            <a:off x="868680" y="2066416"/>
+            <a:ext cx="10607040" cy="207264"/>
+          </a:xfrm>
+          <a:prstGeom prst="rect">
+            <a:avLst/>
+          </a:prstGeom>
+          <a:noFill/>
+        </p:spPr>
+        <p:txBody>
+          <a:bodyPr wrap="square">
+            <a:spAutoFit/>
+          </a:bodyPr>
+          <a:lstStyle/>
+          <a:p>
+            <a:pPr algn="l">
+              <a:lnSpc>
+                <a:spcPct val="125000"/>
+              </a:lnSpc>
+            </a:pPr>
+            <a:r>
+              <a:rPr sz="1200" b="0" i="0">
+                <a:solidFill>
+                  <a:srgbClr val="5A667A"/>
+                </a:solidFill>
+                <a:latin typeface="Segoe UI"/>
+              </a:rPr>
+              <a:t>One answer per round: correct ends it, and so does wrong.</a:t>
+            </a:r>
+          </a:p>
+        </p:txBody>
+      </p:sp>
+      <p:sp>
+        <p:nvSpPr>
+          <p:cNvPr id="8" name="TextBox 7"/>
+          <p:cNvSpPr txBox="1"/>
+          <p:nvPr/>
+        </p:nvSpPr>
+        <p:spPr>
+          <a:xfrm>
+            <a:off x="868680" y="2419985"/>
+            <a:ext cx="10607040" cy="246761"/>
+          </a:xfrm>
+          <a:prstGeom prst="rect">
+            <a:avLst/>
+          </a:prstGeom>
+          <a:noFill/>
+        </p:spPr>
+        <p:txBody>
+          <a:bodyPr wrap="square">
+            <a:spAutoFit/>
+          </a:bodyPr>
+          <a:lstStyle/>
+          <a:p>
+            <a:pPr algn="l">
+              <a:lnSpc>
+                <a:spcPct val="115000"/>
+              </a:lnSpc>
+            </a:pPr>
+            <a:r>
+              <a:rPr sz="1450" b="1" i="0">
+                <a:solidFill>
+                  <a:srgbClr val="141B2D"/>
+                </a:solidFill>
+                <a:latin typeface="Segoe UI"/>
+              </a:rPr>
+              <a:t>step_limit  -  36 actions spent without answering.</a:t>
+            </a:r>
+          </a:p>
+        </p:txBody>
+      </p:sp>
+      <p:sp>
+        <p:nvSpPr>
+          <p:cNvPr id="9" name="TextBox 8"/>
+          <p:cNvSpPr txBox="1"/>
+          <p:nvPr/>
+        </p:nvSpPr>
+        <p:spPr>
+          <a:xfrm>
+            <a:off x="868680" y="2703322"/>
+            <a:ext cx="10607040" cy="207264"/>
+          </a:xfrm>
+          <a:prstGeom prst="rect">
+            <a:avLst/>
+          </a:prstGeom>
+          <a:noFill/>
+        </p:spPr>
+        <p:txBody>
+          <a:bodyPr wrap="square">
+            <a:spAutoFit/>
+          </a:bodyPr>
+          <a:lstStyle/>
+          <a:p>
+            <a:pPr algn="l">
+              <a:lnSpc>
+                <a:spcPct val="125000"/>
+              </a:lnSpc>
+            </a:pPr>
+            <a:r>
+              <a:rPr sz="1200" b="0" i="0">
+                <a:solidFill>
+                  <a:srgbClr val="5A667A"/>
+                </a:solidFill>
+                <a:latin typeface="Segoe UI"/>
+              </a:rPr>
+              <a:t>36 is exactly the number of distinct window positions.</a:t>
+            </a:r>
+          </a:p>
+        </p:txBody>
+      </p:sp>
+      <p:sp>
+        <p:nvSpPr>
+          <p:cNvPr id="10" name="TextBox 9"/>
+          <p:cNvSpPr txBox="1"/>
+          <p:nvPr/>
+        </p:nvSpPr>
+        <p:spPr>
+          <a:xfrm>
+            <a:off x="868680" y="3056890"/>
+            <a:ext cx="10607040" cy="246761"/>
+          </a:xfrm>
+          <a:prstGeom prst="rect">
+            <a:avLst/>
+          </a:prstGeom>
+          <a:noFill/>
+        </p:spPr>
+        <p:txBody>
+          <a:bodyPr wrap="square">
+            <a:spAutoFit/>
+          </a:bodyPr>
+          <a:lstStyle/>
+          <a:p>
+            <a:pPr algn="l">
+              <a:lnSpc>
+                <a:spcPct val="115000"/>
+              </a:lnSpc>
+            </a:pPr>
+            <a:r>
+              <a:rPr sz="1450" b="1" i="0">
+                <a:solidFill>
+                  <a:srgbClr val="141B2D"/>
+                </a:solidFill>
+                <a:latin typeface="Segoe UI"/>
+              </a:rPr>
+              <a:t>invalid_action  -  an unrecognised verb, or no usable action after three attempts.</a:t>
+            </a:r>
+          </a:p>
+        </p:txBody>
+      </p:sp>
+      <p:sp>
+        <p:nvSpPr>
+          <p:cNvPr id="11" name="TextBox 10"/>
+          <p:cNvSpPr txBox="1"/>
+          <p:nvPr/>
+        </p:nvSpPr>
+        <p:spPr>
+          <a:xfrm>
+            <a:off x="868680" y="3340227"/>
+            <a:ext cx="10607040" cy="414528"/>
+          </a:xfrm>
+          <a:prstGeom prst="rect">
+            <a:avLst/>
+          </a:prstGeom>
+          <a:noFill/>
+        </p:spPr>
+        <p:txBody>
+          <a:bodyPr wrap="square">
+            <a:spAutoFit/>
+          </a:bodyPr>
+          <a:lstStyle/>
+          <a:p>
+            <a:pPr algn="l">
+              <a:lnSpc>
+                <a:spcPct val="125000"/>
+              </a:lnSpc>
+            </a:pPr>
+            <a:r>
+              <a:rPr sz="1200" b="0" i="0">
+                <a:solidFill>
+                  <a:srgbClr val="5A667A"/>
+                </a:solidFill>
+                <a:latin typeface="Segoe UI"/>
+              </a:rPr>
+              <a:t>The benchmark scores malformed actions rather than raising, and so does this. The reply is now shown on screen, so the cause is visible instead of guessed at.</a:t>
+            </a:r>
+          </a:p>
+        </p:txBody>
+      </p:sp>
+      <p:sp>
+        <p:nvSpPr>
+          <p:cNvPr id="12" name="TextBox 11"/>
+          <p:cNvSpPr txBox="1"/>
+          <p:nvPr/>
+        </p:nvSpPr>
+        <p:spPr>
+          <a:xfrm>
+            <a:off x="868680" y="3901059"/>
+            <a:ext cx="10607040" cy="246761"/>
+          </a:xfrm>
+          <a:prstGeom prst="rect">
+            <a:avLst/>
+          </a:prstGeom>
+          <a:noFill/>
+        </p:spPr>
+        <p:txBody>
+          <a:bodyPr wrap="square">
+            <a:spAutoFit/>
+          </a:bodyPr>
+          <a:lstStyle/>
+          <a:p>
+            <a:pPr algn="l">
+              <a:lnSpc>
+                <a:spcPct val="115000"/>
+              </a:lnSpc>
+            </a:pPr>
+            <a:r>
+              <a:rPr sz="1450" b="1" i="0">
+                <a:solidFill>
+                  <a:srgbClr val="141B2D"/>
+                </a:solidFill>
+                <a:latin typeface="Segoe UI"/>
+              </a:rPr>
+              <a:t>stopped  -  a person pressed STOP.</a:t>
+            </a:r>
+          </a:p>
+        </p:txBody>
+      </p:sp>
+      <p:sp>
+        <p:nvSpPr>
+          <p:cNvPr id="13" name="TextBox 12"/>
+          <p:cNvSpPr txBox="1"/>
+          <p:nvPr/>
+        </p:nvSpPr>
+        <p:spPr>
+          <a:xfrm>
+            <a:off x="868680" y="4184396"/>
+            <a:ext cx="10607040" cy="207264"/>
+          </a:xfrm>
+          <a:prstGeom prst="rect">
+            <a:avLst/>
+          </a:prstGeom>
+          <a:noFill/>
+        </p:spPr>
+        <p:txBody>
+          <a:bodyPr wrap="square">
+            <a:spAutoFit/>
+          </a:bodyPr>
+          <a:lstStyle/>
+          <a:p>
+            <a:pPr algn="l">
+              <a:lnSpc>
+                <a:spcPct val="125000"/>
+              </a:lnSpc>
+            </a:pPr>
+            <a:r>
+              <a:rPr sz="1200" b="0" i="0">
+                <a:solidFill>
+                  <a:srgbClr val="5A667A"/>
+                </a:solidFill>
+                <a:latin typeface="Segoe UI"/>
+              </a:rPr>
+              <a:t>Kept distinct from running out of steps, because reporting it as the latter was a lie the interface told for several days.</a:t>
+            </a:r>
+          </a:p>
+        </p:txBody>
+      </p:sp>
+    </p:spTree>
+  </p:cSld>
+  <p:clrMapOvr>
+    <a:masterClrMapping/>
+  </p:clrMapOvr>
+</p:sld>
+</file>
+
+<file path=ppt/slides/slide22.xml><?xml version="1.0" encoding="utf-8"?>
+<p:sld xmlns:a="http://schemas.openxmlformats.org/drawingml/2006/main" xmlns:p="http://schemas.openxmlformats.org/presentationml/2006/main" xmlns:r="http://schemas.openxmlformats.org/officeDocument/2006/relationships">
+  <p:cSld>
+    <p:spTree>
+      <p:nvGrpSpPr>
+        <p:cNvPr id="1" name=""/>
+        <p:cNvGrpSpPr/>
+        <p:nvPr/>
+      </p:nvGrpSpPr>
+      <p:grpSpPr/>
+      <p:sp>
+        <p:nvSpPr>
+          <p:cNvPr id="2" name="Rectangle 1"/>
+          <p:cNvSpPr/>
+          <p:nvPr/>
+        </p:nvSpPr>
+        <p:spPr>
+          <a:xfrm>
+            <a:off x="0" y="0"/>
+            <a:ext cx="12191695" cy="6858000"/>
+          </a:xfrm>
+          <a:prstGeom prst="rect">
+            <a:avLst/>
+          </a:prstGeom>
+          <a:solidFill>
+            <a:srgbClr val="FAFBFD"/>
+          </a:solidFill>
+          <a:ln>
+            <a:noFill/>
+          </a:ln>
+          <a:effectLst/>
+        </p:spPr>
+        <p:style>
+          <a:lnRef idx="1">
+            <a:schemeClr val="accent1"/>
+          </a:lnRef>
+          <a:fillRef idx="3">
+            <a:schemeClr val="accent1"/>
+          </a:fillRef>
+          <a:effectRef idx="2">
+            <a:schemeClr val="accent1"/>
+          </a:effectRef>
+          <a:fontRef idx="minor">
+            <a:schemeClr val="lt1"/>
+          </a:fontRef>
+        </p:style>
+        <p:txBody>
+          <a:bodyPr rtlCol="0" anchor="ctr"/>
+          <a:lstStyle/>
+          <a:p>
+            <a:pPr algn="ctr"/>
+          </a:p>
+        </p:txBody>
+      </p:sp>
+      <p:sp>
+        <p:nvSpPr>
+          <p:cNvPr id="3" name="Rectangle 2"/>
+          <p:cNvSpPr/>
+          <p:nvPr/>
+        </p:nvSpPr>
+        <p:spPr>
+          <a:xfrm>
+            <a:off x="640080" y="566928"/>
+            <a:ext cx="82296" cy="420624"/>
+          </a:xfrm>
+          <a:prstGeom prst="rect">
+            <a:avLst/>
+          </a:prstGeom>
+          <a:solidFill>
+            <a:srgbClr val="00A8BF"/>
+          </a:solidFill>
+          <a:ln>
+            <a:noFill/>
+          </a:ln>
+          <a:effectLst/>
+        </p:spPr>
+        <p:style>
+          <a:lnRef idx="1">
+            <a:schemeClr val="accent1"/>
+          </a:lnRef>
+          <a:fillRef idx="3">
+            <a:schemeClr val="accent1"/>
+          </a:fillRef>
+          <a:effectRef idx="2">
+            <a:schemeClr val="accent1"/>
+          </a:effectRef>
+          <a:fontRef idx="minor">
+            <a:schemeClr val="lt1"/>
+          </a:fontRef>
+        </p:style>
+        <p:txBody>
+          <a:bodyPr rtlCol="0" anchor="ctr"/>
+          <a:lstStyle/>
+          <a:p>
+            <a:pPr algn="ctr"/>
+          </a:p>
+        </p:txBody>
+      </p:sp>
+      <p:sp>
+        <p:nvSpPr>
+          <p:cNvPr id="4" name="TextBox 3"/>
+          <p:cNvSpPr txBox="1"/>
+          <p:nvPr/>
+        </p:nvSpPr>
+        <p:spPr>
+          <a:xfrm>
+            <a:off x="868680" y="502920"/>
+            <a:ext cx="10058400" cy="310896"/>
+          </a:xfrm>
+          <a:prstGeom prst="rect">
+            <a:avLst/>
+          </a:prstGeom>
+          <a:noFill/>
+        </p:spPr>
+        <p:txBody>
+          <a:bodyPr wrap="square">
+            <a:spAutoFit/>
+          </a:bodyPr>
+          <a:lstStyle/>
+          <a:p>
+            <a:pPr algn="l">
+              <a:lnSpc>
+                <a:spcPct val="115000"/>
+              </a:lnSpc>
+            </a:pPr>
+            <a:r>
+              <a:rPr sz="1100" b="1" i="0">
+                <a:solidFill>
+                  <a:srgbClr val="5A667A"/>
+                </a:solidFill>
+                <a:latin typeface="Segoe UI"/>
+              </a:rPr>
+              <a:t>DESIGN</a:t>
+            </a:r>
+          </a:p>
+        </p:txBody>
+      </p:sp>
+      <p:sp>
+        <p:nvSpPr>
+          <p:cNvPr id="5" name="TextBox 4"/>
+          <p:cNvSpPr txBox="1"/>
+          <p:nvPr/>
+        </p:nvSpPr>
+        <p:spPr>
+          <a:xfrm>
+            <a:off x="841248" y="841248"/>
+            <a:ext cx="10607040" cy="566928"/>
+          </a:xfrm>
+          <a:prstGeom prst="rect">
+            <a:avLst/>
+          </a:prstGeom>
+          <a:noFill/>
+        </p:spPr>
+        <p:txBody>
+          <a:bodyPr wrap="square">
+            <a:spAutoFit/>
+          </a:bodyPr>
+          <a:lstStyle/>
+          <a:p>
+            <a:pPr algn="l">
+              <a:lnSpc>
+                <a:spcPct val="115000"/>
+              </a:lnSpc>
+            </a:pPr>
+            <a:r>
+              <a:rPr sz="2800" b="1" i="0">
+                <a:solidFill>
+                  <a:srgbClr val="141B2D"/>
+                </a:solidFill>
+                <a:latin typeface="Segoe UI"/>
+              </a:rPr>
+              <a:t>Decisions, and why they went that way</a:t>
+            </a:r>
+          </a:p>
+        </p:txBody>
+      </p:sp>
+      <p:sp>
+        <p:nvSpPr>
+          <p:cNvPr id="6" name="TextBox 5"/>
+          <p:cNvSpPr txBox="1"/>
+          <p:nvPr/>
+        </p:nvSpPr>
+        <p:spPr>
+          <a:xfrm>
+            <a:off x="868680" y="1783080"/>
+            <a:ext cx="10607040" cy="246761"/>
+          </a:xfrm>
+          <a:prstGeom prst="rect">
+            <a:avLst/>
+          </a:prstGeom>
+          <a:noFill/>
+        </p:spPr>
+        <p:txBody>
+          <a:bodyPr wrap="square">
+            <a:spAutoFit/>
+          </a:bodyPr>
+          <a:lstStyle/>
+          <a:p>
+            <a:pPr algn="l">
+              <a:lnSpc>
+                <a:spcPct val="115000"/>
+              </a:lnSpc>
+            </a:pPr>
+            <a:r>
+              <a:rPr sz="1450" b="1" i="0">
+                <a:solidFill>
+                  <a:srgbClr val="141B2D"/>
+                </a:solidFill>
+                <a:latin typeface="Segoe UI"/>
+              </a:rPr>
+              <a:t>ARC first, MNIST-PRO second.</a:t>
+            </a:r>
+          </a:p>
+        </p:txBody>
+      </p:sp>
+      <p:sp>
+        <p:nvSpPr>
+          <p:cNvPr id="7" name="TextBox 6"/>
+          <p:cNvSpPr txBox="1"/>
+          <p:nvPr/>
+        </p:nvSpPr>
+        <p:spPr>
+          <a:xfrm>
+            <a:off x="868680" y="2066416"/>
+            <a:ext cx="10607040" cy="414528"/>
+          </a:xfrm>
+          <a:prstGeom prst="rect">
+            <a:avLst/>
+          </a:prstGeom>
+          <a:noFill/>
+        </p:spPr>
+        <p:txBody>
+          <a:bodyPr wrap="square">
+            <a:spAutoFit/>
+          </a:bodyPr>
+          <a:lstStyle/>
+          <a:p>
+            <a:pPr algn="l">
+              <a:lnSpc>
+                <a:spcPct val="125000"/>
+              </a:lnSpc>
+            </a:pPr>
+            <a:r>
+              <a:rPr sz="1200" b="0" i="0">
+                <a:solidFill>
+                  <a:srgbClr val="5A667A"/>
+                </a:solidFill>
+                <a:latin typeface="Segoe UI"/>
+              </a:rPr>
+              <a:t>ARC asks you to infer a rule in five minutes. That turned out to be the wrong kind of hard for a party game, so a task needing no prior knowledge became the front page.</a:t>
+            </a:r>
+          </a:p>
+        </p:txBody>
+      </p:sp>
+      <p:sp>
+        <p:nvSpPr>
+          <p:cNvPr id="8" name="TextBox 7"/>
+          <p:cNvSpPr txBox="1"/>
+          <p:nvPr/>
+        </p:nvSpPr>
+        <p:spPr>
+          <a:xfrm>
+            <a:off x="868680" y="2590673"/>
+            <a:ext cx="10607040" cy="246761"/>
+          </a:xfrm>
+          <a:prstGeom prst="rect">
+            <a:avLst/>
+          </a:prstGeom>
+          <a:noFill/>
+        </p:spPr>
+        <p:txBody>
+          <a:bodyPr wrap="square">
+            <a:spAutoFit/>
+          </a:bodyPr>
+          <a:lstStyle/>
+          <a:p>
+            <a:pPr algn="l">
+              <a:lnSpc>
+                <a:spcPct val="115000"/>
+              </a:lnSpc>
+            </a:pPr>
+            <a:r>
+              <a:rPr sz="1450" b="1" i="0">
+                <a:solidFill>
+                  <a:srgbClr val="141B2D"/>
+                </a:solidFill>
+                <a:latin typeface="Segoe UI"/>
+              </a:rPr>
+              <a:t>Difficulty measured rather than asserted.</a:t>
+            </a:r>
+          </a:p>
+        </p:txBody>
+      </p:sp>
+      <p:sp>
+        <p:nvSpPr>
+          <p:cNvPr id="9" name="TextBox 8"/>
+          <p:cNvSpPr txBox="1"/>
+          <p:nvPr/>
+        </p:nvSpPr>
+        <p:spPr>
+          <a:xfrm>
+            <a:off x="868680" y="2874010"/>
+            <a:ext cx="10607040" cy="414528"/>
+          </a:xfrm>
+          <a:prstGeom prst="rect">
+            <a:avLst/>
+          </a:prstGeom>
+          <a:noFill/>
+        </p:spPr>
+        <p:txBody>
+          <a:bodyPr wrap="square">
+            <a:spAutoFit/>
+          </a:bodyPr>
+          <a:lstStyle/>
+          <a:p>
+            <a:pPr algn="l">
+              <a:lnSpc>
+                <a:spcPct val="125000"/>
+              </a:lnSpc>
+            </a:pPr>
+            <a:r>
+              <a:rPr sz="1200" b="0" i="0">
+                <a:solidFill>
+                  <a:srgbClr val="5A667A"/>
+                </a:solidFill>
+                <a:latin typeface="Segoe UI"/>
+              </a:rPr>
+              <a:t>For ARC, a classifier found the 19 tasks a single rule explains. For MNIST-PRO, a simulation of 400 digits set the window size: 8x8 tiles end a round in 2 glimpses, 2x2 in 15. 4x4 was the playable middle.</a:t>
+            </a:r>
+          </a:p>
+        </p:txBody>
+      </p:sp>
+      <p:sp>
+        <p:nvSpPr>
+          <p:cNvPr id="10" name="TextBox 9"/>
+          <p:cNvSpPr txBox="1"/>
+          <p:nvPr/>
+        </p:nvSpPr>
+        <p:spPr>
+          <a:xfrm>
+            <a:off x="868680" y="3398266"/>
+            <a:ext cx="10607040" cy="246761"/>
+          </a:xfrm>
+          <a:prstGeom prst="rect">
+            <a:avLst/>
+          </a:prstGeom>
+          <a:noFill/>
+        </p:spPr>
+        <p:txBody>
+          <a:bodyPr wrap="square">
+            <a:spAutoFit/>
+          </a:bodyPr>
+          <a:lstStyle/>
+          <a:p>
+            <a:pPr algn="l">
+              <a:lnSpc>
+                <a:spcPct val="115000"/>
+              </a:lnSpc>
+            </a:pPr>
+            <a:r>
+              <a:rPr sz="1450" b="1" i="0">
+                <a:solidFill>
+                  <a:srgbClr val="141B2D"/>
+                </a:solidFill>
+                <a:latin typeface="Segoe UI"/>
+              </a:rPr>
+              <a:t>Steps, not seconds.</a:t>
+            </a:r>
+          </a:p>
+        </p:txBody>
+      </p:sp>
+      <p:sp>
+        <p:nvSpPr>
+          <p:cNvPr id="11" name="TextBox 10"/>
+          <p:cNvSpPr txBox="1"/>
+          <p:nvPr/>
+        </p:nvSpPr>
+        <p:spPr>
+          <a:xfrm>
+            <a:off x="868680" y="3681603"/>
+            <a:ext cx="10607040" cy="207264"/>
+          </a:xfrm>
+          <a:prstGeom prst="rect">
+            <a:avLst/>
+          </a:prstGeom>
+          <a:noFill/>
+        </p:spPr>
+        <p:txBody>
+          <a:bodyPr wrap="square">
+            <a:spAutoFit/>
+          </a:bodyPr>
+          <a:lstStyle/>
+          <a:p>
+            <a:pPr algn="l">
+              <a:lnSpc>
+                <a:spcPct val="125000"/>
+              </a:lnSpc>
+            </a:pPr>
+            <a:r>
+              <a:rPr sz="1200" b="0" i="0">
+                <a:solidFill>
+                  <a:srgbClr val="5A667A"/>
+                </a:solidFill>
+                <a:latin typeface="Segoe UI"/>
+              </a:rPr>
+              <a:t>Suggested by the first player to look at it, and correct: timing a networked opponent measures latency.</a:t>
+            </a:r>
+          </a:p>
+        </p:txBody>
+      </p:sp>
+      <p:sp>
+        <p:nvSpPr>
+          <p:cNvPr id="12" name="TextBox 11"/>
+          <p:cNvSpPr txBox="1"/>
+          <p:nvPr/>
+        </p:nvSpPr>
+        <p:spPr>
+          <a:xfrm>
+            <a:off x="868680" y="3998595"/>
+            <a:ext cx="10607040" cy="246761"/>
+          </a:xfrm>
+          <a:prstGeom prst="rect">
+            <a:avLst/>
+          </a:prstGeom>
+          <a:noFill/>
+        </p:spPr>
+        <p:txBody>
+          <a:bodyPr wrap="square">
+            <a:spAutoFit/>
+          </a:bodyPr>
+          <a:lstStyle/>
+          <a:p>
+            <a:pPr algn="l">
+              <a:lnSpc>
+                <a:spcPct val="115000"/>
+              </a:lnSpc>
+            </a:pPr>
+            <a:r>
+              <a:rPr sz="1450" b="1" i="0">
+                <a:solidFill>
+                  <a:srgbClr val="141B2D"/>
+                </a:solidFill>
+                <a:latin typeface="Segoe UI"/>
+              </a:rPr>
+              <a:t>The rules panel collapsed by default.</a:t>
+            </a:r>
+          </a:p>
+        </p:txBody>
+      </p:sp>
+      <p:sp>
+        <p:nvSpPr>
+          <p:cNvPr id="13" name="TextBox 12"/>
+          <p:cNvSpPr txBox="1"/>
+          <p:nvPr/>
+        </p:nvSpPr>
+        <p:spPr>
+          <a:xfrm>
+            <a:off x="868680" y="4281932"/>
+            <a:ext cx="10607040" cy="207264"/>
+          </a:xfrm>
+          <a:prstGeom prst="rect">
+            <a:avLst/>
+          </a:prstGeom>
+          <a:noFill/>
+        </p:spPr>
+        <p:txBody>
+          <a:bodyPr wrap="square">
+            <a:spAutoFit/>
+          </a:bodyPr>
+          <a:lstStyle/>
+          <a:p>
+            <a:pPr algn="l">
+              <a:lnSpc>
+                <a:spcPct val="125000"/>
+              </a:lnSpc>
+            </a:pPr>
+            <a:r>
+              <a:rPr sz="1200" b="0" i="0">
+                <a:solidFill>
+                  <a:srgbClr val="5A667A"/>
+                </a:solidFill>
+                <a:latin typeface="Segoe UI"/>
+              </a:rPr>
+              <a:t>It occupied the top of both games before anyone had pressed anything.</a:t>
+            </a:r>
+          </a:p>
+        </p:txBody>
+      </p:sp>
+    </p:spTree>
+  </p:cSld>
+  <p:clrMapOvr>
+    <a:masterClrMapping/>
+  </p:clrMapOvr>
+</p:sld>
+</file>
+
+<file path=ppt/slides/slide23.xml><?xml version="1.0" encoding="utf-8"?>
+<p:sld xmlns:a="http://schemas.openxmlformats.org/drawingml/2006/main" xmlns:p="http://schemas.openxmlformats.org/presentationml/2006/main" xmlns:r="http://schemas.openxmlformats.org/officeDocument/2006/relationships">
+  <p:cSld>
+    <p:spTree>
+      <p:nvGrpSpPr>
+        <p:cNvPr id="1" name=""/>
+        <p:cNvGrpSpPr/>
+        <p:nvPr/>
+      </p:nvGrpSpPr>
+      <p:grpSpPr/>
+      <p:sp>
+        <p:nvSpPr>
+          <p:cNvPr id="2" name="Rectangle 1"/>
+          <p:cNvSpPr/>
+          <p:nvPr/>
+        </p:nvSpPr>
+        <p:spPr>
+          <a:xfrm>
+            <a:off x="0" y="0"/>
+            <a:ext cx="12191695" cy="6858000"/>
+          </a:xfrm>
+          <a:prstGeom prst="rect">
+            <a:avLst/>
+          </a:prstGeom>
+          <a:solidFill>
+            <a:srgbClr val="FAFBFD"/>
+          </a:solidFill>
+          <a:ln>
+            <a:noFill/>
+          </a:ln>
+          <a:effectLst/>
+        </p:spPr>
+        <p:style>
+          <a:lnRef idx="1">
+            <a:schemeClr val="accent1"/>
+          </a:lnRef>
+          <a:fillRef idx="3">
+            <a:schemeClr val="accent1"/>
+          </a:fillRef>
+          <a:effectRef idx="2">
+            <a:schemeClr val="accent1"/>
+          </a:effectRef>
+          <a:fontRef idx="minor">
+            <a:schemeClr val="lt1"/>
+          </a:fontRef>
+        </p:style>
+        <p:txBody>
+          <a:bodyPr rtlCol="0" anchor="ctr"/>
+          <a:lstStyle/>
+          <a:p>
+            <a:pPr algn="ctr"/>
+          </a:p>
+        </p:txBody>
+      </p:sp>
+      <p:sp>
+        <p:nvSpPr>
+          <p:cNvPr id="3" name="Rectangle 2"/>
+          <p:cNvSpPr/>
+          <p:nvPr/>
+        </p:nvSpPr>
+        <p:spPr>
+          <a:xfrm>
+            <a:off x="640080" y="566928"/>
+            <a:ext cx="82296" cy="420624"/>
+          </a:xfrm>
+          <a:prstGeom prst="rect">
+            <a:avLst/>
+          </a:prstGeom>
+          <a:solidFill>
+            <a:srgbClr val="00A8BF"/>
+          </a:solidFill>
+          <a:ln>
+            <a:noFill/>
+          </a:ln>
+          <a:effectLst/>
+        </p:spPr>
+        <p:style>
+          <a:lnRef idx="1">
+            <a:schemeClr val="accent1"/>
+          </a:lnRef>
+          <a:fillRef idx="3">
+            <a:schemeClr val="accent1"/>
+          </a:fillRef>
+          <a:effectRef idx="2">
+            <a:schemeClr val="accent1"/>
+          </a:effectRef>
+          <a:fontRef idx="minor">
+            <a:schemeClr val="lt1"/>
+          </a:fontRef>
+        </p:style>
+        <p:txBody>
+          <a:bodyPr rtlCol="0" anchor="ctr"/>
+          <a:lstStyle/>
+          <a:p>
+            <a:pPr algn="ctr"/>
+          </a:p>
+        </p:txBody>
+      </p:sp>
+      <p:sp>
+        <p:nvSpPr>
+          <p:cNvPr id="4" name="TextBox 3"/>
+          <p:cNvSpPr txBox="1"/>
+          <p:nvPr/>
+        </p:nvSpPr>
+        <p:spPr>
+          <a:xfrm>
+            <a:off x="868680" y="502920"/>
+            <a:ext cx="10058400" cy="310896"/>
+          </a:xfrm>
+          <a:prstGeom prst="rect">
+            <a:avLst/>
+          </a:prstGeom>
+          <a:noFill/>
+        </p:spPr>
+        <p:txBody>
+          <a:bodyPr wrap="square">
+            <a:spAutoFit/>
+          </a:bodyPr>
+          <a:lstStyle/>
+          <a:p>
+            <a:pPr algn="l">
+              <a:lnSpc>
+                <a:spcPct val="115000"/>
+              </a:lnSpc>
+            </a:pPr>
+            <a:r>
+              <a:rPr sz="1100" b="1" i="0">
+                <a:solidFill>
+                  <a:srgbClr val="5A667A"/>
+                </a:solidFill>
+                <a:latin typeface="Segoe UI"/>
+              </a:rPr>
+              <a:t>WHAT BUILDING IT TAUGHT US</a:t>
+            </a:r>
+          </a:p>
+        </p:txBody>
+      </p:sp>
+      <p:sp>
+        <p:nvSpPr>
+          <p:cNvPr id="5" name="TextBox 4"/>
+          <p:cNvSpPr txBox="1"/>
+          <p:nvPr/>
+        </p:nvSpPr>
+        <p:spPr>
+          <a:xfrm>
+            <a:off x="841248" y="841248"/>
+            <a:ext cx="10607040" cy="566928"/>
+          </a:xfrm>
+          <a:prstGeom prst="rect">
+            <a:avLst/>
+          </a:prstGeom>
+          <a:noFill/>
+        </p:spPr>
+        <p:txBody>
+          <a:bodyPr wrap="square">
+            <a:spAutoFit/>
+          </a:bodyPr>
+          <a:lstStyle/>
+          <a:p>
+            <a:pPr algn="l">
+              <a:lnSpc>
+                <a:spcPct val="115000"/>
+              </a:lnSpc>
+            </a:pPr>
+            <a:r>
+              <a:rPr sz="2800" b="1" i="0">
+                <a:solidFill>
+                  <a:srgbClr val="141B2D"/>
+                </a:solidFill>
+                <a:latin typeface="Segoe UI"/>
+              </a:rPr>
+              <a:t>The tests agreed with me more often than they should have</a:t>
+            </a:r>
+          </a:p>
+        </p:txBody>
+      </p:sp>
+      <p:sp>
+        <p:nvSpPr>
+          <p:cNvPr id="6" name="TextBox 5"/>
+          <p:cNvSpPr txBox="1"/>
+          <p:nvPr/>
+        </p:nvSpPr>
+        <p:spPr>
+          <a:xfrm>
+            <a:off x="868680" y="1783080"/>
+            <a:ext cx="10607040" cy="246761"/>
+          </a:xfrm>
+          <a:prstGeom prst="rect">
+            <a:avLst/>
+          </a:prstGeom>
+          <a:noFill/>
+        </p:spPr>
+        <p:txBody>
+          <a:bodyPr wrap="square">
+            <a:spAutoFit/>
+          </a:bodyPr>
+          <a:lstStyle/>
+          <a:p>
+            <a:pPr algn="l">
+              <a:lnSpc>
+                <a:spcPct val="115000"/>
+              </a:lnSpc>
+            </a:pPr>
+            <a:r>
+              <a:rPr sz="1450" b="1" i="0">
+                <a:solidFill>
+                  <a:srgbClr val="141B2D"/>
+                </a:solidFill>
+                <a:latin typeface="Segoe UI"/>
+              </a:rPr>
+              <a:t>Five real bugs were caught by looking at screenshots, not by assertions.</a:t>
+            </a:r>
+          </a:p>
+        </p:txBody>
+      </p:sp>
+      <p:sp>
+        <p:nvSpPr>
+          <p:cNvPr id="7" name="TextBox 6"/>
+          <p:cNvSpPr txBox="1"/>
+          <p:nvPr/>
+        </p:nvSpPr>
+        <p:spPr>
+          <a:xfrm>
+            <a:off x="868680" y="2066416"/>
+            <a:ext cx="10607040" cy="414528"/>
+          </a:xfrm>
+          <a:prstGeom prst="rect">
+            <a:avLst/>
+          </a:prstGeom>
+          <a:noFill/>
+        </p:spPr>
+        <p:txBody>
+          <a:bodyPr wrap="square">
+            <a:spAutoFit/>
+          </a:bodyPr>
+          <a:lstStyle/>
+          <a:p>
+            <a:pPr algn="l">
+              <a:lnSpc>
+                <a:spcPct val="125000"/>
+              </a:lnSpc>
+            </a:pPr>
+            <a:r>
+              <a:rPr sz="1200" b="0" i="0">
+                <a:solidFill>
+                  <a:srgbClr val="5A667A"/>
+                </a:solidFill>
+                <a:latin typeface="Segoe UI"/>
+              </a:rPr>
+              <a:t>A correct answer reported as 'Wrong - it answered null'. Panels frozen on a stale state. Overlays sitting on top of live canvases. Sensible actions rejected on formatting. A reply cut off by a token budget and scored as malformed.</a:t>
+            </a:r>
+          </a:p>
+        </p:txBody>
+      </p:sp>
+      <p:sp>
+        <p:nvSpPr>
+          <p:cNvPr id="8" name="TextBox 7"/>
+          <p:cNvSpPr txBox="1"/>
+          <p:nvPr/>
+        </p:nvSpPr>
+        <p:spPr>
+          <a:xfrm>
+            <a:off x="868680" y="2581529"/>
+            <a:ext cx="10607040" cy="246761"/>
+          </a:xfrm>
+          <a:prstGeom prst="rect">
+            <a:avLst/>
+          </a:prstGeom>
+          <a:noFill/>
+        </p:spPr>
+        <p:txBody>
+          <a:bodyPr wrap="square">
+            <a:spAutoFit/>
+          </a:bodyPr>
+          <a:lstStyle/>
+          <a:p>
+            <a:pPr algn="l">
+              <a:lnSpc>
+                <a:spcPct val="115000"/>
+              </a:lnSpc>
+            </a:pPr>
+            <a:r>
+              <a:rPr sz="1450" b="1" i="0">
+                <a:solidFill>
+                  <a:srgbClr val="141B2D"/>
+                </a:solidFill>
+                <a:latin typeface="Segoe UI"/>
+              </a:rPr>
+              <a:t>The common thread: asserting intent instead of outcome.</a:t>
+            </a:r>
+          </a:p>
+        </p:txBody>
+      </p:sp>
+      <p:sp>
+        <p:nvSpPr>
+          <p:cNvPr id="9" name="TextBox 8"/>
+          <p:cNvSpPr txBox="1"/>
+          <p:nvPr/>
+        </p:nvSpPr>
+        <p:spPr>
+          <a:xfrm>
+            <a:off x="868680" y="2864866"/>
+            <a:ext cx="10607040" cy="414528"/>
+          </a:xfrm>
+          <a:prstGeom prst="rect">
+            <a:avLst/>
+          </a:prstGeom>
+          <a:noFill/>
+        </p:spPr>
+        <p:txBody>
+          <a:bodyPr wrap="square">
+            <a:spAutoFit/>
+          </a:bodyPr>
+          <a:lstStyle/>
+          <a:p>
+            <a:pPr algn="l">
+              <a:lnSpc>
+                <a:spcPct val="125000"/>
+              </a:lnSpc>
+            </a:pPr>
+            <a:r>
+              <a:rPr sz="1200" b="0" i="0">
+                <a:solidFill>
+                  <a:srgbClr val="5A667A"/>
+                </a:solidFill>
+                <a:latin typeface="Segoe UI"/>
+              </a:rPr>
+              <a:t>Tests checked that hidden was set - it was - while the element stayed on screen, because an explicit CSS display beats the hidden attribute. Every such test passed throughout.</a:t>
+            </a:r>
+          </a:p>
+        </p:txBody>
+      </p:sp>
+      <p:sp>
+        <p:nvSpPr>
+          <p:cNvPr id="10" name="TextBox 9"/>
+          <p:cNvSpPr txBox="1"/>
+          <p:nvPr/>
+        </p:nvSpPr>
+        <p:spPr>
+          <a:xfrm>
+            <a:off x="868680" y="3379978"/>
+            <a:ext cx="10607040" cy="246761"/>
+          </a:xfrm>
+          <a:prstGeom prst="rect">
+            <a:avLst/>
+          </a:prstGeom>
+          <a:noFill/>
+        </p:spPr>
+        <p:txBody>
+          <a:bodyPr wrap="square">
+            <a:spAutoFit/>
+          </a:bodyPr>
+          <a:lstStyle/>
+          <a:p>
+            <a:pPr algn="l">
+              <a:lnSpc>
+                <a:spcPct val="115000"/>
+              </a:lnSpc>
+            </a:pPr>
+            <a:r>
+              <a:rPr sz="1450" b="1" i="0">
+                <a:solidFill>
+                  <a:srgbClr val="141B2D"/>
+                </a:solidFill>
+                <a:latin typeface="Segoe UI"/>
+              </a:rPr>
+              <a:t>Fixes applied per-place rather than once come back.</a:t>
+            </a:r>
+          </a:p>
+        </p:txBody>
+      </p:sp>
+      <p:sp>
+        <p:nvSpPr>
+          <p:cNvPr id="11" name="TextBox 10"/>
+          <p:cNvSpPr txBox="1"/>
+          <p:nvPr/>
+        </p:nvSpPr>
+        <p:spPr>
+          <a:xfrm>
+            <a:off x="868680" y="3663314"/>
+            <a:ext cx="10607040" cy="414528"/>
+          </a:xfrm>
+          <a:prstGeom prst="rect">
+            <a:avLst/>
+          </a:prstGeom>
+          <a:noFill/>
+        </p:spPr>
+        <p:txBody>
+          <a:bodyPr wrap="square">
+            <a:spAutoFit/>
+          </a:bodyPr>
+          <a:lstStyle/>
+          <a:p>
+            <a:pPr algn="l">
+              <a:lnSpc>
+                <a:spcPct val="125000"/>
+              </a:lnSpc>
+            </a:pPr>
+            <a:r>
+              <a:rPr sz="1200" b="0" i="0">
+                <a:solidFill>
+                  <a:srgbClr val="5A667A"/>
+                </a:solidFill>
+                <a:latin typeface="Segoe UI"/>
+              </a:rPr>
+              <a:t>The hidden-attribute bug was patched in four components before being fixed globally. The token-budget check existed in two other code paths and was missing from the third.</a:t>
+            </a:r>
+          </a:p>
+        </p:txBody>
+      </p:sp>
+      <p:sp>
+        <p:nvSpPr>
+          <p:cNvPr id="12" name="TextBox 11"/>
+          <p:cNvSpPr txBox="1"/>
+          <p:nvPr/>
+        </p:nvSpPr>
+        <p:spPr>
+          <a:xfrm>
+            <a:off x="868680" y="4178427"/>
+            <a:ext cx="10607040" cy="246761"/>
+          </a:xfrm>
+          <a:prstGeom prst="rect">
+            <a:avLst/>
+          </a:prstGeom>
+          <a:noFill/>
+        </p:spPr>
+        <p:txBody>
+          <a:bodyPr wrap="square">
+            <a:spAutoFit/>
+          </a:bodyPr>
+          <a:lstStyle/>
+          <a:p>
+            <a:pPr algn="l">
+              <a:lnSpc>
+                <a:spcPct val="115000"/>
+              </a:lnSpc>
+            </a:pPr>
+            <a:r>
+              <a:rPr sz="1450" b="1" i="0">
+                <a:solidFill>
+                  <a:srgbClr val="141B2D"/>
+                </a:solidFill>
+                <a:latin typeface="Segoe UI"/>
+              </a:rPr>
+              <a:t>Diagnostics are a feature.</a:t>
+            </a:r>
+          </a:p>
+        </p:txBody>
+      </p:sp>
+      <p:sp>
+        <p:nvSpPr>
+          <p:cNvPr id="13" name="TextBox 12"/>
+          <p:cNvSpPr txBox="1"/>
+          <p:nvPr/>
+        </p:nvSpPr>
+        <p:spPr>
+          <a:xfrm>
+            <a:off x="868680" y="4461764"/>
+            <a:ext cx="10607040" cy="207264"/>
+          </a:xfrm>
+          <a:prstGeom prst="rect">
+            <a:avLst/>
+          </a:prstGeom>
+          <a:noFill/>
+        </p:spPr>
+        <p:txBody>
+          <a:bodyPr wrap="square">
+            <a:spAutoFit/>
+          </a:bodyPr>
+          <a:lstStyle/>
+          <a:p>
+            <a:pPr algn="l">
+              <a:lnSpc>
+                <a:spcPct val="125000"/>
+              </a:lnSpc>
+            </a:pPr>
+            <a:r>
+              <a:rPr sz="1200" b="0" i="0">
+                <a:solidFill>
+                  <a:srgbClr val="5A667A"/>
+                </a:solidFill>
+                <a:latin typeface="Segoe UI"/>
+              </a:rPr>
+              <a:t>The failure message now shows the model's actual reply. The bug that took three rounds to identify would have been obvious in one.</a:t>
+            </a:r>
+          </a:p>
+        </p:txBody>
+      </p:sp>
+    </p:spTree>
+  </p:cSld>
+  <p:clrMapOvr>
+    <a:masterClrMapping/>
+  </p:clrMapOvr>
+</p:sld>
+</file>
+
+<file path=ppt/slides/slide24.xml><?xml version="1.0" encoding="utf-8"?>
+<p:sld xmlns:a="http://schemas.openxmlformats.org/drawingml/2006/main" xmlns:p="http://schemas.openxmlformats.org/presentationml/2006/main" xmlns:r="http://schemas.openxmlformats.org/officeDocument/2006/relationships">
+  <p:cSld>
+    <p:spTree>
+      <p:nvGrpSpPr>
+        <p:cNvPr id="1" name=""/>
+        <p:cNvGrpSpPr/>
+        <p:nvPr/>
+      </p:nvGrpSpPr>
+      <p:grpSpPr/>
+      <p:sp>
+        <p:nvSpPr>
+          <p:cNvPr id="2" name="Rectangle 1"/>
+          <p:cNvSpPr/>
+          <p:nvPr/>
+        </p:nvSpPr>
+        <p:spPr>
+          <a:xfrm>
+            <a:off x="0" y="0"/>
+            <a:ext cx="12191695" cy="6858000"/>
+          </a:xfrm>
+          <a:prstGeom prst="rect">
+            <a:avLst/>
+          </a:prstGeom>
+          <a:solidFill>
+            <a:srgbClr val="FAFBFD"/>
+          </a:solidFill>
+          <a:ln>
+            <a:noFill/>
+          </a:ln>
+          <a:effectLst/>
+        </p:spPr>
+        <p:style>
+          <a:lnRef idx="1">
+            <a:schemeClr val="accent1"/>
+          </a:lnRef>
+          <a:fillRef idx="3">
+            <a:schemeClr val="accent1"/>
+          </a:fillRef>
+          <a:effectRef idx="2">
+            <a:schemeClr val="accent1"/>
+          </a:effectRef>
+          <a:fontRef idx="minor">
+            <a:schemeClr val="lt1"/>
+          </a:fontRef>
+        </p:style>
+        <p:txBody>
+          <a:bodyPr rtlCol="0" anchor="ctr"/>
+          <a:lstStyle/>
+          <a:p>
+            <a:pPr algn="ctr"/>
+          </a:p>
+        </p:txBody>
+      </p:sp>
+      <p:sp>
+        <p:nvSpPr>
+          <p:cNvPr id="3" name="Rectangle 2"/>
+          <p:cNvSpPr/>
+          <p:nvPr/>
+        </p:nvSpPr>
+        <p:spPr>
+          <a:xfrm>
+            <a:off x="640080" y="566928"/>
+            <a:ext cx="82296" cy="420624"/>
+          </a:xfrm>
+          <a:prstGeom prst="rect">
+            <a:avLst/>
+          </a:prstGeom>
+          <a:solidFill>
+            <a:srgbClr val="00A8BF"/>
+          </a:solidFill>
+          <a:ln>
+            <a:noFill/>
+          </a:ln>
+          <a:effectLst/>
+        </p:spPr>
+        <p:style>
+          <a:lnRef idx="1">
+            <a:schemeClr val="accent1"/>
+          </a:lnRef>
+          <a:fillRef idx="3">
+            <a:schemeClr val="accent1"/>
+          </a:fillRef>
+          <a:effectRef idx="2">
+            <a:schemeClr val="accent1"/>
+          </a:effectRef>
+          <a:fontRef idx="minor">
+            <a:schemeClr val="lt1"/>
+          </a:fontRef>
+        </p:style>
+        <p:txBody>
+          <a:bodyPr rtlCol="0" anchor="ctr"/>
+          <a:lstStyle/>
+          <a:p>
+            <a:pPr algn="ctr"/>
+          </a:p>
+        </p:txBody>
+      </p:sp>
+      <p:sp>
+        <p:nvSpPr>
+          <p:cNvPr id="4" name="TextBox 3"/>
+          <p:cNvSpPr txBox="1"/>
+          <p:nvPr/>
+        </p:nvSpPr>
+        <p:spPr>
+          <a:xfrm>
+            <a:off x="868680" y="502920"/>
+            <a:ext cx="10058400" cy="310896"/>
+          </a:xfrm>
+          <a:prstGeom prst="rect">
+            <a:avLst/>
+          </a:prstGeom>
+          <a:noFill/>
+        </p:spPr>
+        <p:txBody>
+          <a:bodyPr wrap="square">
+            <a:spAutoFit/>
+          </a:bodyPr>
+          <a:lstStyle/>
+          <a:p>
+            <a:pPr algn="l">
+              <a:lnSpc>
+                <a:spcPct val="115000"/>
+              </a:lnSpc>
+            </a:pPr>
+            <a:r>
+              <a:rPr sz="1100" b="1" i="0">
+                <a:solidFill>
+                  <a:srgbClr val="5A667A"/>
+                </a:solidFill>
+                <a:latin typeface="Segoe UI"/>
+              </a:rPr>
+              <a:t>CREDITS</a:t>
+            </a:r>
+          </a:p>
+        </p:txBody>
+      </p:sp>
+      <p:sp>
+        <p:nvSpPr>
+          <p:cNvPr id="5" name="TextBox 4"/>
+          <p:cNvSpPr txBox="1"/>
+          <p:nvPr/>
+        </p:nvSpPr>
+        <p:spPr>
+          <a:xfrm>
+            <a:off x="841248" y="841248"/>
+            <a:ext cx="10607040" cy="566928"/>
+          </a:xfrm>
+          <a:prstGeom prst="rect">
+            <a:avLst/>
+          </a:prstGeom>
+          <a:noFill/>
+        </p:spPr>
+        <p:txBody>
+          <a:bodyPr wrap="square">
+            <a:spAutoFit/>
+          </a:bodyPr>
+          <a:lstStyle/>
+          <a:p>
+            <a:pPr algn="l">
+              <a:lnSpc>
+                <a:spcPct val="115000"/>
+              </a:lnSpc>
+            </a:pPr>
+            <a:r>
+              <a:rPr sz="2800" b="1" i="0">
+                <a:solidFill>
+                  <a:srgbClr val="141B2D"/>
+                </a:solidFill>
+                <a:latin typeface="Segoe UI"/>
+              </a:rPr>
+              <a:t>Standing on other people's work</a:t>
+            </a:r>
+          </a:p>
+        </p:txBody>
+      </p:sp>
+      <p:sp>
+        <p:nvSpPr>
+          <p:cNvPr id="6" name="TextBox 5"/>
+          <p:cNvSpPr txBox="1"/>
+          <p:nvPr/>
+        </p:nvSpPr>
+        <p:spPr>
+          <a:xfrm>
+            <a:off x="868680" y="1783080"/>
+            <a:ext cx="10607040" cy="246761"/>
+          </a:xfrm>
+          <a:prstGeom prst="rect">
+            <a:avLst/>
+          </a:prstGeom>
+          <a:noFill/>
+        </p:spPr>
+        <p:txBody>
+          <a:bodyPr wrap="square">
+            <a:spAutoFit/>
+          </a:bodyPr>
+          <a:lstStyle/>
+          <a:p>
+            <a:pPr algn="l">
+              <a:lnSpc>
+                <a:spcPct val="115000"/>
+              </a:lnSpc>
+            </a:pPr>
+            <a:r>
+              <a:rPr sz="1450" b="1" i="0">
+                <a:solidFill>
+                  <a:srgbClr val="141B2D"/>
+                </a:solidFill>
+                <a:latin typeface="Segoe UI"/>
+              </a:rPr>
+              <a:t>MNIST-PRO  -  MIT</a:t>
+            </a:r>
+          </a:p>
+        </p:txBody>
+      </p:sp>
+      <p:sp>
+        <p:nvSpPr>
+          <p:cNvPr id="7" name="TextBox 6"/>
+          <p:cNvSpPr txBox="1"/>
+          <p:nvPr/>
+        </p:nvSpPr>
+        <p:spPr>
+          <a:xfrm>
+            <a:off x="868680" y="2066416"/>
+            <a:ext cx="10607040" cy="414528"/>
+          </a:xfrm>
+          <a:prstGeom prst="rect">
+            <a:avLst/>
+          </a:prstGeom>
+          <a:noFill/>
+        </p:spPr>
+        <p:txBody>
+          <a:bodyPr wrap="square">
+            <a:spAutoFit/>
+          </a:bodyPr>
+          <a:lstStyle/>
+          <a:p>
+            <a:pPr algn="l">
+              <a:lnSpc>
+                <a:spcPct val="125000"/>
+              </a:lnSpc>
+            </a:pPr>
+            <a:r>
+              <a:rPr sz="1200" b="0" i="0">
+                <a:solidFill>
+                  <a:srgbClr val="5A667A"/>
+                </a:solidFill>
+                <a:latin typeface="Segoe UI"/>
+              </a:rPr>
+              <a:t>Toh, Majumder, Liu, Chen and Poria. DeCLaRe Lab, Nanyang Technological University, and A*STAR. arXiv:2608.31022  ·  github.com/declare-lab/MNIST-PRO</a:t>
+            </a:r>
+          </a:p>
+        </p:txBody>
+      </p:sp>
+      <p:sp>
+        <p:nvSpPr>
+          <p:cNvPr id="8" name="TextBox 7"/>
+          <p:cNvSpPr txBox="1"/>
+          <p:nvPr/>
+        </p:nvSpPr>
+        <p:spPr>
+          <a:xfrm>
+            <a:off x="868680" y="2663825"/>
+            <a:ext cx="10607040" cy="246761"/>
+          </a:xfrm>
+          <a:prstGeom prst="rect">
+            <a:avLst/>
+          </a:prstGeom>
+          <a:noFill/>
+        </p:spPr>
+        <p:txBody>
+          <a:bodyPr wrap="square">
+            <a:spAutoFit/>
+          </a:bodyPr>
+          <a:lstStyle/>
+          <a:p>
+            <a:pPr algn="l">
+              <a:lnSpc>
+                <a:spcPct val="115000"/>
+              </a:lnSpc>
+            </a:pPr>
+            <a:r>
+              <a:rPr sz="1450" b="1" i="0">
+                <a:solidFill>
+                  <a:srgbClr val="141B2D"/>
+                </a:solidFill>
+                <a:latin typeface="Segoe UI"/>
+              </a:rPr>
+              <a:t>MNIST  -  CC BY-SA 3.0</a:t>
+            </a:r>
+          </a:p>
+        </p:txBody>
+      </p:sp>
+      <p:sp>
+        <p:nvSpPr>
+          <p:cNvPr id="9" name="TextBox 8"/>
+          <p:cNvSpPr txBox="1"/>
+          <p:nvPr/>
+        </p:nvSpPr>
+        <p:spPr>
+          <a:xfrm>
+            <a:off x="868680" y="2947162"/>
+            <a:ext cx="10607040" cy="207264"/>
+          </a:xfrm>
+          <a:prstGeom prst="rect">
+            <a:avLst/>
+          </a:prstGeom>
+          <a:noFill/>
+        </p:spPr>
+        <p:txBody>
+          <a:bodyPr wrap="square">
+            <a:spAutoFit/>
+          </a:bodyPr>
+          <a:lstStyle/>
+          <a:p>
+            <a:pPr algn="l">
+              <a:lnSpc>
+                <a:spcPct val="125000"/>
+              </a:lnSpc>
+            </a:pPr>
+            <a:r>
+              <a:rPr sz="1200" b="0" i="0">
+                <a:solidFill>
+                  <a:srgbClr val="5A667A"/>
+                </a:solidFill>
+                <a:latin typeface="Segoe UI"/>
+              </a:rPr>
+              <a:t>LeCun, Cortes and Burges, derived from NIST Special Database 19.</a:t>
+            </a:r>
+          </a:p>
+        </p:txBody>
+      </p:sp>
+      <p:sp>
+        <p:nvSpPr>
+          <p:cNvPr id="10" name="TextBox 9"/>
+          <p:cNvSpPr txBox="1"/>
+          <p:nvPr/>
+        </p:nvSpPr>
+        <p:spPr>
+          <a:xfrm>
+            <a:off x="868680" y="3337306"/>
+            <a:ext cx="10607040" cy="246761"/>
+          </a:xfrm>
+          <a:prstGeom prst="rect">
+            <a:avLst/>
+          </a:prstGeom>
+          <a:noFill/>
+        </p:spPr>
+        <p:txBody>
+          <a:bodyPr wrap="square">
+            <a:spAutoFit/>
+          </a:bodyPr>
+          <a:lstStyle/>
+          <a:p>
+            <a:pPr algn="l">
+              <a:lnSpc>
+                <a:spcPct val="115000"/>
+              </a:lnSpc>
+            </a:pPr>
+            <a:r>
+              <a:rPr sz="1450" b="1" i="0">
+                <a:solidFill>
+                  <a:srgbClr val="141B2D"/>
+                </a:solidFill>
+                <a:latin typeface="Segoe UI"/>
+              </a:rPr>
+              <a:t>ARC-AGI-1  -  Apache 2.0</a:t>
+            </a:r>
+          </a:p>
+        </p:txBody>
+      </p:sp>
+      <p:sp>
+        <p:nvSpPr>
+          <p:cNvPr id="11" name="TextBox 10"/>
+          <p:cNvSpPr txBox="1"/>
+          <p:nvPr/>
+        </p:nvSpPr>
+        <p:spPr>
+          <a:xfrm>
+            <a:off x="868680" y="3620643"/>
+            <a:ext cx="10607040" cy="207264"/>
+          </a:xfrm>
+          <a:prstGeom prst="rect">
+            <a:avLst/>
+          </a:prstGeom>
+          <a:noFill/>
+        </p:spPr>
+        <p:txBody>
+          <a:bodyPr wrap="square">
+            <a:spAutoFit/>
+          </a:bodyPr>
+          <a:lstStyle/>
+          <a:p>
+            <a:pPr algn="l">
+              <a:lnSpc>
+                <a:spcPct val="125000"/>
+              </a:lnSpc>
+            </a:pPr>
+            <a:r>
+              <a:rPr sz="1200" b="0" i="0">
+                <a:solidFill>
+                  <a:srgbClr val="5A667A"/>
+                </a:solidFill>
+                <a:latin typeface="Segoe UI"/>
+              </a:rPr>
+              <a:t>Francois Chollet. The public training set, used unmodified.</a:t>
+            </a:r>
+          </a:p>
+        </p:txBody>
+      </p:sp>
+      <p:sp>
+        <p:nvSpPr>
+          <p:cNvPr id="12" name="TextBox 11"/>
+          <p:cNvSpPr txBox="1"/>
+          <p:nvPr/>
+        </p:nvSpPr>
+        <p:spPr>
+          <a:xfrm>
+            <a:off x="868680" y="4010787"/>
+            <a:ext cx="10607040" cy="246761"/>
+          </a:xfrm>
+          <a:prstGeom prst="rect">
+            <a:avLst/>
+          </a:prstGeom>
+          <a:noFill/>
+        </p:spPr>
+        <p:txBody>
+          <a:bodyPr wrap="square">
+            <a:spAutoFit/>
+          </a:bodyPr>
+          <a:lstStyle/>
+          <a:p>
+            <a:pPr algn="l">
+              <a:lnSpc>
+                <a:spcPct val="115000"/>
+              </a:lnSpc>
+            </a:pPr>
+            <a:r>
+              <a:rPr sz="1450" b="1" i="0">
+                <a:solidFill>
+                  <a:srgbClr val="141B2D"/>
+                </a:solidFill>
+                <a:latin typeface="Segoe UI"/>
+              </a:rPr>
+              <a:t>Licences are retained in the repository.</a:t>
+            </a:r>
+          </a:p>
+        </p:txBody>
+      </p:sp>
+      <p:sp>
+        <p:nvSpPr>
+          <p:cNvPr id="13" name="TextBox 12"/>
+          <p:cNvSpPr txBox="1"/>
+          <p:nvPr/>
+        </p:nvSpPr>
+        <p:spPr>
+          <a:xfrm>
+            <a:off x="868680" y="4294124"/>
+            <a:ext cx="10607040" cy="207264"/>
+          </a:xfrm>
+          <a:prstGeom prst="rect">
+            <a:avLst/>
+          </a:prstGeom>
+          <a:noFill/>
+        </p:spPr>
+        <p:txBody>
+          <a:bodyPr wrap="square">
+            <a:spAutoFit/>
+          </a:bodyPr>
+          <a:lstStyle/>
+          <a:p>
+            <a:pPr algn="l">
+              <a:lnSpc>
+                <a:spcPct val="125000"/>
+              </a:lnSpc>
+            </a:pPr>
+            <a:r>
+              <a:rPr sz="1200" b="0" i="0">
+                <a:solidFill>
+                  <a:srgbClr val="5A667A"/>
+                </a:solidFill>
+                <a:latin typeface="Segoe UI"/>
+              </a:rPr>
+              <a:t>third_party/mnist-pro/LICENSE, with attribution files beside the generated data.</a:t>
+            </a:r>
+          </a:p>
+        </p:txBody>
+      </p:sp>
+    </p:spTree>
+  </p:cSld>
+  <p:clrMapOvr>
+    <a:masterClrMapping/>
+  </p:clrMapOvr>
+</p:sld>
+</file>
+
+<file path=ppt/slides/slide25.xml><?xml version="1.0" encoding="utf-8"?>
+<p:sld xmlns:a="http://schemas.openxmlformats.org/drawingml/2006/main" xmlns:p="http://schemas.openxmlformats.org/presentationml/2006/main" xmlns:r="http://schemas.openxmlformats.org/officeDocument/2006/relationships">
+  <p:cSld>
+    <p:spTree>
+      <p:nvGrpSpPr>
+        <p:cNvPr id="1" name=""/>
+        <p:cNvGrpSpPr/>
+        <p:nvPr/>
+      </p:nvGrpSpPr>
+      <p:grpSpPr/>
+      <p:sp>
+        <p:nvSpPr>
+          <p:cNvPr id="2" name="Rectangle 1"/>
+          <p:cNvSpPr/>
+          <p:nvPr/>
+        </p:nvSpPr>
+        <p:spPr>
+          <a:xfrm>
+            <a:off x="0" y="0"/>
+            <a:ext cx="12191695" cy="6858000"/>
+          </a:xfrm>
+          <a:prstGeom prst="rect">
+            <a:avLst/>
+          </a:prstGeom>
+          <a:solidFill>
+            <a:srgbClr val="0E1A2B"/>
+          </a:solidFill>
+          <a:ln>
+            <a:noFill/>
+          </a:ln>
+          <a:effectLst/>
+        </p:spPr>
+        <p:style>
+          <a:lnRef idx="1">
+            <a:schemeClr val="accent1"/>
+          </a:lnRef>
+          <a:fillRef idx="3">
+            <a:schemeClr val="accent1"/>
+          </a:fillRef>
+          <a:effectRef idx="2">
+            <a:schemeClr val="accent1"/>
+          </a:effectRef>
+          <a:fontRef idx="minor">
+            <a:schemeClr val="lt1"/>
+          </a:fontRef>
+        </p:style>
+        <p:txBody>
+          <a:bodyPr rtlCol="0" anchor="ctr"/>
+          <a:lstStyle/>
+          <a:p>
+            <a:pPr algn="ctr"/>
+          </a:p>
+        </p:txBody>
+      </p:sp>
+      <p:sp>
+        <p:nvSpPr>
+          <p:cNvPr id="3" name="Rectangle 2"/>
+          <p:cNvSpPr/>
+          <p:nvPr/>
+        </p:nvSpPr>
+        <p:spPr>
+          <a:xfrm>
+            <a:off x="0" y="2697480"/>
+            <a:ext cx="12191695" cy="41148"/>
+          </a:xfrm>
+          <a:prstGeom prst="rect">
+            <a:avLst/>
+          </a:prstGeom>
+          <a:solidFill>
+            <a:srgbClr val="00A8BF"/>
+          </a:solidFill>
+          <a:ln>
+            <a:noFill/>
+          </a:ln>
+          <a:effectLst/>
+        </p:spPr>
+        <p:style>
+          <a:lnRef idx="1">
+            <a:schemeClr val="accent1"/>
+          </a:lnRef>
+          <a:fillRef idx="3">
+            <a:schemeClr val="accent1"/>
+          </a:fillRef>
+          <a:effectRef idx="2">
+            <a:schemeClr val="accent1"/>
+          </a:effectRef>
+          <a:fontRef idx="minor">
+            <a:schemeClr val="lt1"/>
+          </a:fontRef>
+        </p:style>
+        <p:txBody>
+          <a:bodyPr rtlCol="0" anchor="ctr"/>
+          <a:lstStyle/>
+          <a:p>
+            <a:pPr algn="ctr"/>
+          </a:p>
+        </p:txBody>
+      </p:sp>
+      <p:sp>
+        <p:nvSpPr>
+          <p:cNvPr id="4" name="TextBox 3"/>
+          <p:cNvSpPr txBox="1"/>
+          <p:nvPr/>
+        </p:nvSpPr>
+        <p:spPr>
+          <a:xfrm>
+            <a:off x="914400" y="1645920"/>
+            <a:ext cx="10515600" cy="822960"/>
+          </a:xfrm>
+          <a:prstGeom prst="rect">
+            <a:avLst/>
+          </a:prstGeom>
+          <a:noFill/>
+        </p:spPr>
+        <p:txBody>
+          <a:bodyPr wrap="square">
+            <a:spAutoFit/>
+          </a:bodyPr>
+          <a:lstStyle/>
+          <a:p>
+            <a:pPr algn="l">
+              <a:lnSpc>
+                <a:spcPct val="115000"/>
+              </a:lnSpc>
+            </a:pPr>
+            <a:r>
+              <a:rPr sz="3800" b="1" i="0">
+                <a:solidFill>
+                  <a:srgbClr val="FFFFFF"/>
+                </a:solidFill>
+                <a:latin typeface="Segoe UI"/>
+              </a:rPr>
+              <a:t>Play it</a:t>
+            </a:r>
+          </a:p>
+        </p:txBody>
+      </p:sp>
+      <p:sp>
+        <p:nvSpPr>
+          <p:cNvPr id="5" name="TextBox 4"/>
+          <p:cNvSpPr txBox="1"/>
+          <p:nvPr/>
+        </p:nvSpPr>
+        <p:spPr>
+          <a:xfrm>
+            <a:off x="914400" y="2971800"/>
+            <a:ext cx="10515600" cy="2194560"/>
+          </a:xfrm>
+          <a:prstGeom prst="rect">
+            <a:avLst/>
+          </a:prstGeom>
+          <a:noFill/>
+        </p:spPr>
+        <p:txBody>
+          <a:bodyPr wrap="square">
+            <a:spAutoFit/>
+          </a:bodyPr>
+          <a:lstStyle/>
+          <a:p>
+            <a:pPr algn="l">
+              <a:lnSpc>
+                <a:spcPct val="190000"/>
+              </a:lnSpc>
+            </a:pPr>
+            <a:r>
+              <a:rPr sz="1550" b="0" i="0">
+                <a:solidFill>
+                  <a:srgbClr val="D4DEEA"/>
+                </a:solidFill>
+                <a:latin typeface="Segoe UI"/>
+              </a:rPr>
+              <a:t>MNIST-PRO        panandi.github.io/mnistpro</a:t>
+            </a:r>
+          </a:p>
+          <a:p>
+            <a:pPr algn="l">
+              <a:lnSpc>
+                <a:spcPct val="190000"/>
+              </a:lnSpc>
+            </a:pPr>
+            <a:r>
+              <a:rPr sz="1550" b="0" i="0">
+                <a:solidFill>
+                  <a:srgbClr val="D4DEEA"/>
+                </a:solidFill>
+                <a:latin typeface="Segoe UI"/>
+              </a:rPr>
+              <a:t>ARC Race         panandi.github.io/mnistpro/arc.html</a:t>
+            </a:r>
+          </a:p>
+          <a:p>
+            <a:pPr algn="l">
+              <a:lnSpc>
+                <a:spcPct val="190000"/>
+              </a:lnSpc>
+            </a:pPr>
+            <a:r>
+              <a:rPr sz="1550" b="0" i="0">
+                <a:solidFill>
+                  <a:srgbClr val="D4DEEA"/>
+                </a:solidFill>
+                <a:latin typeface="Segoe UI"/>
+              </a:rPr>
+              <a:t>Player's guide   panandi.github.io/mnistpro/guide.html</a:t>
+            </a:r>
+          </a:p>
+          <a:p>
+            <a:pPr algn="l">
+              <a:lnSpc>
+                <a:spcPct val="190000"/>
+              </a:lnSpc>
+            </a:pPr>
+            <a:r>
+              <a:rPr sz="1550" b="0" i="0">
+                <a:solidFill>
+                  <a:srgbClr val="D4DEEA"/>
+                </a:solidFill>
+                <a:latin typeface="Segoe UI"/>
+              </a:rPr>
+              <a:t>Source           github.com/panandi/mnistpro</a:t>
+            </a:r>
+          </a:p>
+        </p:txBody>
+      </p:sp>
+      <p:sp>
+        <p:nvSpPr>
+          <p:cNvPr id="6" name="TextBox 5"/>
+          <p:cNvSpPr txBox="1"/>
+          <p:nvPr/>
+        </p:nvSpPr>
+        <p:spPr>
+          <a:xfrm>
+            <a:off x="914400" y="5715000"/>
+            <a:ext cx="10515600" cy="548640"/>
+          </a:xfrm>
+          <a:prstGeom prst="rect">
+            <a:avLst/>
+          </a:prstGeom>
+          <a:noFill/>
+        </p:spPr>
+        <p:txBody>
+          <a:bodyPr wrap="square">
+            <a:spAutoFit/>
+          </a:bodyPr>
+          <a:lstStyle/>
+          <a:p>
+            <a:pPr algn="l">
+              <a:lnSpc>
+                <a:spcPct val="115000"/>
+              </a:lnSpc>
+            </a:pPr>
+            <a:r>
+              <a:rPr sz="1300" b="0" i="0">
+                <a:solidFill>
+                  <a:srgbClr val="8D9DB2"/>
+                </a:solidFill>
+                <a:latin typeface="Segoe UI"/>
+              </a:rPr>
+              <a:t>No install, no sign-up, no key needed to play solo. Bring an OpenRouter key if you want to race the model.</a:t>
             </a:r>
           </a:p>
         </p:txBody>

</xml_diff>